<commit_message>
Functies slides - iets aangepast (niet inhoudelijk)
</commit_message>
<xml_diff>
--- a/slides/S2_Functions.pptx
+++ b/slides/S2_Functions.pptx
@@ -130,6 +130,11 @@
       </a:defRPr>
     </a:lvl9pPr>
   </p:defaultTextStyle>
+  <p:extLst>
+    <p:ext uri="{EFAFB233-063F-42B5-8137-9DF3F51BA10A}">
+      <p15:sldGuideLst xmlns:p15="http://schemas.microsoft.com/office/powerpoint/2012/main"/>
+    </p:ext>
+  </p:extLst>
 </p:presentation>
 </file>
 
@@ -282,7 +287,7 @@
           <a:p>
             <a:fld id="{3A7CBCB4-1EFE-4E3B-9C8A-BCC4F06648F3}" type="datetimeFigureOut">
               <a:rPr lang="en-NL" smtClean="0"/>
-              <a:t>25/02/2026</a:t>
+              <a:t>09/14/2026</a:t>
             </a:fld>
             <a:endParaRPr lang="en-NL"/>
           </a:p>
@@ -336,7 +341,7 @@
           <a:p>
             <a:fld id="{E76345A7-8EB6-4FDF-A52B-7AB511DDD562}" type="slidenum">
               <a:rPr lang="en-NL" smtClean="0"/>
-              <a:t>‹#›</a:t>
+              <a:t>‹nr.›</a:t>
             </a:fld>
             <a:endParaRPr lang="en-NL"/>
           </a:p>
@@ -482,7 +487,7 @@
           <a:p>
             <a:fld id="{3A7CBCB4-1EFE-4E3B-9C8A-BCC4F06648F3}" type="datetimeFigureOut">
               <a:rPr lang="en-NL" smtClean="0"/>
-              <a:t>25/02/2026</a:t>
+              <a:t>09/14/2026</a:t>
             </a:fld>
             <a:endParaRPr lang="en-NL"/>
           </a:p>
@@ -536,7 +541,7 @@
           <a:p>
             <a:fld id="{E76345A7-8EB6-4FDF-A52B-7AB511DDD562}" type="slidenum">
               <a:rPr lang="en-NL" smtClean="0"/>
-              <a:t>‹#›</a:t>
+              <a:t>‹nr.›</a:t>
             </a:fld>
             <a:endParaRPr lang="en-NL"/>
           </a:p>
@@ -692,7 +697,7 @@
           <a:p>
             <a:fld id="{3A7CBCB4-1EFE-4E3B-9C8A-BCC4F06648F3}" type="datetimeFigureOut">
               <a:rPr lang="en-NL" smtClean="0"/>
-              <a:t>25/02/2026</a:t>
+              <a:t>09/14/2026</a:t>
             </a:fld>
             <a:endParaRPr lang="en-NL"/>
           </a:p>
@@ -746,7 +751,7 @@
           <a:p>
             <a:fld id="{E76345A7-8EB6-4FDF-A52B-7AB511DDD562}" type="slidenum">
               <a:rPr lang="en-NL" smtClean="0"/>
-              <a:t>‹#›</a:t>
+              <a:t>‹nr.›</a:t>
             </a:fld>
             <a:endParaRPr lang="en-NL"/>
           </a:p>
@@ -892,7 +897,7 @@
           <a:p>
             <a:fld id="{3A7CBCB4-1EFE-4E3B-9C8A-BCC4F06648F3}" type="datetimeFigureOut">
               <a:rPr lang="en-NL" smtClean="0"/>
-              <a:t>25/02/2026</a:t>
+              <a:t>09/14/2026</a:t>
             </a:fld>
             <a:endParaRPr lang="en-NL"/>
           </a:p>
@@ -946,7 +951,7 @@
           <a:p>
             <a:fld id="{E76345A7-8EB6-4FDF-A52B-7AB511DDD562}" type="slidenum">
               <a:rPr lang="en-NL" smtClean="0"/>
-              <a:t>‹#›</a:t>
+              <a:t>‹nr.›</a:t>
             </a:fld>
             <a:endParaRPr lang="en-NL"/>
           </a:p>
@@ -1168,7 +1173,7 @@
           <a:p>
             <a:fld id="{3A7CBCB4-1EFE-4E3B-9C8A-BCC4F06648F3}" type="datetimeFigureOut">
               <a:rPr lang="en-NL" smtClean="0"/>
-              <a:t>25/02/2026</a:t>
+              <a:t>09/14/2026</a:t>
             </a:fld>
             <a:endParaRPr lang="en-NL"/>
           </a:p>
@@ -1222,7 +1227,7 @@
           <a:p>
             <a:fld id="{E76345A7-8EB6-4FDF-A52B-7AB511DDD562}" type="slidenum">
               <a:rPr lang="en-NL" smtClean="0"/>
-              <a:t>‹#›</a:t>
+              <a:t>‹nr.›</a:t>
             </a:fld>
             <a:endParaRPr lang="en-NL"/>
           </a:p>
@@ -1436,7 +1441,7 @@
           <a:p>
             <a:fld id="{3A7CBCB4-1EFE-4E3B-9C8A-BCC4F06648F3}" type="datetimeFigureOut">
               <a:rPr lang="en-NL" smtClean="0"/>
-              <a:t>25/02/2026</a:t>
+              <a:t>09/14/2026</a:t>
             </a:fld>
             <a:endParaRPr lang="en-NL"/>
           </a:p>
@@ -1490,7 +1495,7 @@
           <a:p>
             <a:fld id="{E76345A7-8EB6-4FDF-A52B-7AB511DDD562}" type="slidenum">
               <a:rPr lang="en-NL" smtClean="0"/>
-              <a:t>‹#›</a:t>
+              <a:t>‹nr.›</a:t>
             </a:fld>
             <a:endParaRPr lang="en-NL"/>
           </a:p>
@@ -1851,7 +1856,7 @@
           <a:p>
             <a:fld id="{3A7CBCB4-1EFE-4E3B-9C8A-BCC4F06648F3}" type="datetimeFigureOut">
               <a:rPr lang="en-NL" smtClean="0"/>
-              <a:t>25/02/2026</a:t>
+              <a:t>09/14/2026</a:t>
             </a:fld>
             <a:endParaRPr lang="en-NL"/>
           </a:p>
@@ -1905,7 +1910,7 @@
           <a:p>
             <a:fld id="{E76345A7-8EB6-4FDF-A52B-7AB511DDD562}" type="slidenum">
               <a:rPr lang="en-NL" smtClean="0"/>
-              <a:t>‹#›</a:t>
+              <a:t>‹nr.›</a:t>
             </a:fld>
             <a:endParaRPr lang="en-NL"/>
           </a:p>
@@ -1993,7 +1998,7 @@
           <a:p>
             <a:fld id="{3A7CBCB4-1EFE-4E3B-9C8A-BCC4F06648F3}" type="datetimeFigureOut">
               <a:rPr lang="en-NL" smtClean="0"/>
-              <a:t>25/02/2026</a:t>
+              <a:t>09/14/2026</a:t>
             </a:fld>
             <a:endParaRPr lang="en-NL"/>
           </a:p>
@@ -2047,7 +2052,7 @@
           <a:p>
             <a:fld id="{E76345A7-8EB6-4FDF-A52B-7AB511DDD562}" type="slidenum">
               <a:rPr lang="en-NL" smtClean="0"/>
-              <a:t>‹#›</a:t>
+              <a:t>‹nr.›</a:t>
             </a:fld>
             <a:endParaRPr lang="en-NL"/>
           </a:p>
@@ -2106,7 +2111,7 @@
           <a:p>
             <a:fld id="{3A7CBCB4-1EFE-4E3B-9C8A-BCC4F06648F3}" type="datetimeFigureOut">
               <a:rPr lang="en-NL" smtClean="0"/>
-              <a:t>25/02/2026</a:t>
+              <a:t>09/14/2026</a:t>
             </a:fld>
             <a:endParaRPr lang="en-NL"/>
           </a:p>
@@ -2160,7 +2165,7 @@
           <a:p>
             <a:fld id="{E76345A7-8EB6-4FDF-A52B-7AB511DDD562}" type="slidenum">
               <a:rPr lang="en-NL" smtClean="0"/>
-              <a:t>‹#›</a:t>
+              <a:t>‹nr.›</a:t>
             </a:fld>
             <a:endParaRPr lang="en-NL"/>
           </a:p>
@@ -2419,7 +2424,7 @@
           <a:p>
             <a:fld id="{3A7CBCB4-1EFE-4E3B-9C8A-BCC4F06648F3}" type="datetimeFigureOut">
               <a:rPr lang="en-NL" smtClean="0"/>
-              <a:t>25/02/2026</a:t>
+              <a:t>09/14/2026</a:t>
             </a:fld>
             <a:endParaRPr lang="en-NL"/>
           </a:p>
@@ -2473,7 +2478,7 @@
           <a:p>
             <a:fld id="{E76345A7-8EB6-4FDF-A52B-7AB511DDD562}" type="slidenum">
               <a:rPr lang="en-NL" smtClean="0"/>
-              <a:t>‹#›</a:t>
+              <a:t>‹nr.›</a:t>
             </a:fld>
             <a:endParaRPr lang="en-NL"/>
           </a:p>
@@ -2708,7 +2713,7 @@
           <a:p>
             <a:fld id="{3A7CBCB4-1EFE-4E3B-9C8A-BCC4F06648F3}" type="datetimeFigureOut">
               <a:rPr lang="en-NL" smtClean="0"/>
-              <a:t>25/02/2026</a:t>
+              <a:t>09/14/2026</a:t>
             </a:fld>
             <a:endParaRPr lang="en-NL"/>
           </a:p>
@@ -2762,7 +2767,7 @@
           <a:p>
             <a:fld id="{E76345A7-8EB6-4FDF-A52B-7AB511DDD562}" type="slidenum">
               <a:rPr lang="en-NL" smtClean="0"/>
-              <a:t>‹#›</a:t>
+              <a:t>‹nr.›</a:t>
             </a:fld>
             <a:endParaRPr lang="en-NL"/>
           </a:p>
@@ -2951,7 +2956,7 @@
           <a:p>
             <a:fld id="{3A7CBCB4-1EFE-4E3B-9C8A-BCC4F06648F3}" type="datetimeFigureOut">
               <a:rPr lang="en-NL" smtClean="0"/>
-              <a:t>25/02/2026</a:t>
+              <a:t>09/14/2026</a:t>
             </a:fld>
             <a:endParaRPr lang="en-NL"/>
           </a:p>
@@ -3041,7 +3046,7 @@
           <a:p>
             <a:fld id="{E76345A7-8EB6-4FDF-A52B-7AB511DDD562}" type="slidenum">
               <a:rPr lang="en-NL" smtClean="0"/>
-              <a:t>‹#›</a:t>
+              <a:t>‹nr.›</a:t>
             </a:fld>
             <a:endParaRPr lang="en-NL"/>
           </a:p>
@@ -3559,7 +3564,7 @@
         <p:spPr>
           <a:xfrm>
             <a:off x="838200" y="2506662"/>
-            <a:ext cx="10515600" cy="4351338"/>
+            <a:ext cx="10515600" cy="3071178"/>
           </a:xfrm>
         </p:spPr>
         <p:txBody>
@@ -4050,18 +4055,36 @@
             <a:pPr lvl="1"/>
             <a:r>
               <a:rPr lang="nl-NL" noProof="0" dirty="0"/>
-              <a:t>Zelf gedefiniëerde types</a:t>
-            </a:r>
+              <a:t>Zelf </a:t>
+            </a:r>
+            <a:r>
+              <a:rPr lang="nl-NL" noProof="0"/>
+              <a:t>gedefiniëerde types</a:t>
+            </a:r>
+            <a:br>
+              <a:rPr lang="nl-NL" noProof="0"/>
+            </a:br>
+            <a:r>
+              <a:rPr lang="nl-NL" noProof="0"/>
+              <a:t>of</a:t>
+            </a:r>
+            <a:endParaRPr lang="nl-NL" noProof="0" dirty="0"/>
           </a:p>
           <a:p>
             <a:pPr lvl="1"/>
             <a:r>
               <a:rPr lang="nl-NL" dirty="0"/>
-              <a:t>Niets: void</a:t>
-            </a:r>
-          </a:p>
-          <a:p>
-            <a:pPr lvl="1"/>
+              <a:t>Niets: </a:t>
+            </a:r>
+            <a:r>
+              <a:rPr lang="nl-NL" i="1" dirty="0"/>
+              <a:t>void</a:t>
+            </a:r>
+          </a:p>
+          <a:p>
+            <a:pPr marL="457200" lvl="1" indent="0">
+              <a:buNone/>
+            </a:pPr>
             <a:endParaRPr lang="nl-NL" noProof="0" dirty="0"/>
           </a:p>
           <a:p>
@@ -4326,10 +4349,21 @@
                   <a:srgbClr val="FFFFFF"/>
                 </a:highlight>
               </a:rPr>
-              <a:t> square</a:t>
-            </a:r>
-            <a:r>
-              <a:rPr lang="nl-NL" sz="2800" b="1" dirty="0">
+              <a:t> </a:t>
+            </a:r>
+            <a:r>
+              <a:rPr lang="nl-NL" sz="2800">
+                <a:solidFill>
+                  <a:srgbClr val="000000"/>
+                </a:solidFill>
+                <a:highlight>
+                  <a:srgbClr val="FFFFFF"/>
+                </a:highlight>
+              </a:rPr>
+              <a:t>square</a:t>
+            </a:r>
+            <a:r>
+              <a:rPr lang="nl-NL" sz="2800" b="1">
                 <a:solidFill>
                   <a:srgbClr val="000080"/>
                 </a:solidFill>
@@ -4337,10 +4371,10 @@
                   <a:srgbClr val="FFFFFF"/>
                 </a:highlight>
               </a:rPr>
-              <a:t>(</a:t>
-            </a:r>
-            <a:r>
-              <a:rPr lang="nl-NL" sz="2800" b="0" dirty="0">
+              <a:t>( </a:t>
+            </a:r>
+            <a:r>
+              <a:rPr lang="nl-NL" sz="2800" b="0">
                 <a:solidFill>
                   <a:srgbClr val="8000FF"/>
                 </a:solidFill>
@@ -4351,7 +4385,7 @@
               <a:t>int</a:t>
             </a:r>
             <a:r>
-              <a:rPr lang="nl-NL" sz="2800" b="0" dirty="0">
+              <a:rPr lang="nl-NL" sz="2800" b="0">
                 <a:solidFill>
                   <a:srgbClr val="000000"/>
                 </a:solidFill>
@@ -4359,10 +4393,10 @@
                   <a:srgbClr val="FFFFFF"/>
                 </a:highlight>
               </a:rPr>
-              <a:t> num</a:t>
-            </a:r>
-            <a:r>
-              <a:rPr lang="nl-NL" sz="2800" b="1" dirty="0">
+              <a:t> num </a:t>
+            </a:r>
+            <a:r>
+              <a:rPr lang="nl-NL" sz="2800" b="1">
                 <a:solidFill>
                   <a:srgbClr val="000080"/>
                 </a:solidFill>
@@ -4370,7 +4404,7 @@
                   <a:srgbClr val="FFFFFF"/>
                 </a:highlight>
               </a:rPr>
-              <a:t>){</a:t>
+              <a:t>) {</a:t>
             </a:r>
             <a:endParaRPr lang="nl-NL" sz="2800" b="0" dirty="0">
               <a:solidFill>
@@ -4521,10 +4555,21 @@
                   <a:srgbClr val="FFFFFF"/>
                 </a:highlight>
               </a:rPr>
-              <a:t> main</a:t>
-            </a:r>
-            <a:r>
-              <a:rPr lang="nl-NL" sz="2800" b="1" dirty="0">
+              <a:t> </a:t>
+            </a:r>
+            <a:r>
+              <a:rPr lang="nl-NL" sz="2800" b="0">
+                <a:solidFill>
+                  <a:srgbClr val="000000"/>
+                </a:solidFill>
+                <a:highlight>
+                  <a:srgbClr val="FFFFFF"/>
+                </a:highlight>
+              </a:rPr>
+              <a:t>main</a:t>
+            </a:r>
+            <a:r>
+              <a:rPr lang="nl-NL" sz="2800" b="1">
                 <a:solidFill>
                   <a:srgbClr val="000080"/>
                 </a:solidFill>
@@ -4532,7 +4577,7 @@
                   <a:srgbClr val="FFFFFF"/>
                 </a:highlight>
               </a:rPr>
-              <a:t>(){</a:t>
+              <a:t>() {</a:t>
             </a:r>
             <a:endParaRPr lang="nl-NL" sz="2800" b="0" dirty="0">
               <a:solidFill>
@@ -4852,7 +4897,7 @@
               <a:t>Mag </a:t>
             </a:r>
             <a:r>
-              <a:rPr lang="nl-NL" dirty="0"/>
+              <a:rPr lang="nl-NL" i="1" dirty="0"/>
               <a:t>bijna</a:t>
             </a:r>
             <a:r>
@@ -4912,9 +4957,38 @@
               <a:rPr lang="nl-NL" dirty="0">
                 <a:sym typeface="Wingdings" panose="05000000000000000000" pitchFamily="2" charset="2"/>
               </a:rPr>
-              <a:t>Maarja.. je kunt ook niet echt iets met een void type</a:t>
-            </a:r>
-            <a:endParaRPr lang="nl-NL" noProof="0" dirty="0"/>
+              <a:t>Maarja.. je kunt ook niet echt iets met een </a:t>
+            </a:r>
+            <a:r>
+              <a:rPr lang="nl-NL">
+                <a:sym typeface="Wingdings" panose="05000000000000000000" pitchFamily="2" charset="2"/>
+              </a:rPr>
+              <a:t>void type</a:t>
+            </a:r>
+          </a:p>
+          <a:p>
+            <a:pPr lvl="1"/>
+            <a:r>
+              <a:rPr lang="nl-NL">
+                <a:sym typeface="Wingdings" panose="05000000000000000000" pitchFamily="2" charset="2"/>
+              </a:rPr>
+              <a:t>De parameterlijst mag wel </a:t>
+            </a:r>
+            <a:r>
+              <a:rPr lang="nl-NL" i="1">
+                <a:sym typeface="Wingdings" panose="05000000000000000000" pitchFamily="2" charset="2"/>
+              </a:rPr>
+              <a:t>leeg</a:t>
+            </a:r>
+            <a:r>
+              <a:rPr lang="nl-NL">
+                <a:sym typeface="Wingdings" panose="05000000000000000000" pitchFamily="2" charset="2"/>
+              </a:rPr>
+              <a:t> zijn: ()</a:t>
+            </a:r>
+            <a:endParaRPr lang="nl-NL" dirty="0">
+              <a:sym typeface="Wingdings" panose="05000000000000000000" pitchFamily="2" charset="2"/>
+            </a:endParaRPr>
           </a:p>
         </p:txBody>
       </p:sp>
@@ -5025,7 +5099,62 @@
                   <a:srgbClr val="FFFFFF"/>
                 </a:highlight>
               </a:rPr>
-              <a:t> sum</a:t>
+              <a:t> </a:t>
+            </a:r>
+            <a:r>
+              <a:rPr lang="en-US" sz="2800">
+                <a:solidFill>
+                  <a:srgbClr val="000000"/>
+                </a:solidFill>
+                <a:highlight>
+                  <a:srgbClr val="FFFFFF"/>
+                </a:highlight>
+              </a:rPr>
+              <a:t>sum</a:t>
+            </a:r>
+            <a:r>
+              <a:rPr lang="en-US" sz="2800" b="1">
+                <a:solidFill>
+                  <a:srgbClr val="000080"/>
+                </a:solidFill>
+                <a:highlight>
+                  <a:srgbClr val="FFFFFF"/>
+                </a:highlight>
+              </a:rPr>
+              <a:t>( </a:t>
+            </a:r>
+            <a:r>
+              <a:rPr lang="en-US" sz="2800" b="0">
+                <a:solidFill>
+                  <a:srgbClr val="8000FF"/>
+                </a:solidFill>
+                <a:highlight>
+                  <a:srgbClr val="FFFFFF"/>
+                </a:highlight>
+              </a:rPr>
+              <a:t>int</a:t>
+            </a:r>
+            <a:r>
+              <a:rPr lang="en-US" sz="2800" b="0">
+                <a:solidFill>
+                  <a:srgbClr val="000000"/>
+                </a:solidFill>
+                <a:highlight>
+                  <a:srgbClr val="FFFFFF"/>
+                </a:highlight>
+              </a:rPr>
+              <a:t> </a:t>
+            </a:r>
+            <a:r>
+              <a:rPr lang="en-US" sz="2800" b="0" dirty="0">
+                <a:solidFill>
+                  <a:srgbClr val="000000"/>
+                </a:solidFill>
+                <a:highlight>
+                  <a:srgbClr val="FFFFFF"/>
+                </a:highlight>
+              </a:rPr>
+              <a:t>num1</a:t>
             </a:r>
             <a:r>
               <a:rPr lang="en-US" sz="2800" b="1" dirty="0">
@@ -5036,11 +5165,22 @@
                   <a:srgbClr val="FFFFFF"/>
                 </a:highlight>
               </a:rPr>
-              <a:t>(</a:t>
+              <a:t>,</a:t>
             </a:r>
             <a:r>
               <a:rPr lang="en-US" sz="2800" b="0" dirty="0">
                 <a:solidFill>
+                  <a:srgbClr val="000000"/>
+                </a:solidFill>
+                <a:highlight>
+                  <a:srgbClr val="FFFFFF"/>
+                </a:highlight>
+              </a:rPr>
+              <a:t> </a:t>
+            </a:r>
+            <a:r>
+              <a:rPr lang="en-US" sz="2800" b="0" dirty="0">
+                <a:solidFill>
                   <a:srgbClr val="8000FF"/>
                 </a:solidFill>
                 <a:highlight>
@@ -5058,7 +5198,40 @@
                   <a:srgbClr val="FFFFFF"/>
                 </a:highlight>
               </a:rPr>
-              <a:t> num1</a:t>
+              <a:t> num2, </a:t>
+            </a:r>
+            <a:r>
+              <a:rPr lang="en-US">
+                <a:solidFill>
+                  <a:srgbClr val="8000FF"/>
+                </a:solidFill>
+                <a:highlight>
+                  <a:srgbClr val="FFFFFF"/>
+                </a:highlight>
+              </a:rPr>
+              <a:t>int</a:t>
+            </a:r>
+            <a:r>
+              <a:rPr lang="en-US">
+                <a:solidFill>
+                  <a:srgbClr val="000000"/>
+                </a:solidFill>
+                <a:highlight>
+                  <a:srgbClr val="FFFFFF"/>
+                </a:highlight>
+              </a:rPr>
+              <a:t> num3 </a:t>
+            </a:r>
+            <a:r>
+              <a:rPr lang="en-US" sz="2800" b="1">
+                <a:solidFill>
+                  <a:srgbClr val="000080"/>
+                </a:solidFill>
+                <a:highlight>
+                  <a:srgbClr val="FFFFFF"/>
+                </a:highlight>
+              </a:rPr>
+              <a:t>) {</a:t>
             </a:r>
             <a:r>
               <a:rPr lang="en-US" sz="2800" b="1" dirty="0">
@@ -5069,73 +5242,7 @@
                   <a:srgbClr val="FFFFFF"/>
                 </a:highlight>
               </a:rPr>
-              <a:t>,</a:t>
-            </a:r>
-            <a:r>
-              <a:rPr lang="en-US" sz="2800" b="0" dirty="0">
-                <a:solidFill>
-                  <a:srgbClr val="000000"/>
-                </a:solidFill>
-                <a:highlight>
-                  <a:srgbClr val="FFFFFF"/>
-                </a:highlight>
-              </a:rPr>
-              <a:t> </a:t>
-            </a:r>
-            <a:r>
-              <a:rPr lang="en-US" sz="2800" b="0" dirty="0">
-                <a:solidFill>
-                  <a:srgbClr val="8000FF"/>
-                </a:solidFill>
-                <a:highlight>
-                  <a:srgbClr val="FFFFFF"/>
-                </a:highlight>
-              </a:rPr>
-              <a:t>int</a:t>
-            </a:r>
-            <a:r>
-              <a:rPr lang="en-US" sz="2800" b="0" dirty="0">
-                <a:solidFill>
-                  <a:srgbClr val="000000"/>
-                </a:solidFill>
-                <a:highlight>
-                  <a:srgbClr val="FFFFFF"/>
-                </a:highlight>
-              </a:rPr>
-              <a:t> num2, </a:t>
-            </a:r>
-            <a:r>
-              <a:rPr lang="en-US" dirty="0">
-                <a:solidFill>
-                  <a:srgbClr val="8000FF"/>
-                </a:solidFill>
-                <a:highlight>
-                  <a:srgbClr val="FFFFFF"/>
-                </a:highlight>
-              </a:rPr>
-              <a:t>int</a:t>
-            </a:r>
-            <a:r>
-              <a:rPr lang="en-US" dirty="0">
-                <a:solidFill>
-                  <a:srgbClr val="000000"/>
-                </a:solidFill>
-                <a:highlight>
-                  <a:srgbClr val="FFFFFF"/>
-                </a:highlight>
-              </a:rPr>
-              <a:t> num3</a:t>
-            </a:r>
-            <a:r>
-              <a:rPr lang="en-US" sz="2800" b="1" dirty="0">
-                <a:solidFill>
-                  <a:srgbClr val="000080"/>
-                </a:solidFill>
-                <a:highlight>
-                  <a:srgbClr val="FFFFFF"/>
-                </a:highlight>
-              </a:rPr>
-              <a:t>){		</a:t>
+              <a:t>		</a:t>
             </a:r>
             <a:r>
               <a:rPr lang="en-US" sz="2800" b="1" dirty="0">
@@ -5288,7 +5395,51 @@
                   <a:srgbClr val="FFFFFF"/>
                 </a:highlight>
               </a:rPr>
-              <a:t> getChar</a:t>
+              <a:t> </a:t>
+            </a:r>
+            <a:r>
+              <a:rPr lang="nl-NL" sz="2800">
+                <a:solidFill>
+                  <a:srgbClr val="000000"/>
+                </a:solidFill>
+                <a:highlight>
+                  <a:srgbClr val="FFFFFF"/>
+                </a:highlight>
+              </a:rPr>
+              <a:t>getChar</a:t>
+            </a:r>
+            <a:r>
+              <a:rPr lang="nl-NL" sz="2800" b="1">
+                <a:solidFill>
+                  <a:srgbClr val="000080"/>
+                </a:solidFill>
+                <a:highlight>
+                  <a:srgbClr val="FFFFFF"/>
+                </a:highlight>
+              </a:rPr>
+              <a:t>( </a:t>
+            </a:r>
+            <a:r>
+              <a:rPr lang="nl-NL" sz="2800" b="0">
+                <a:solidFill>
+                  <a:srgbClr val="000000"/>
+                </a:solidFill>
+                <a:highlight>
+                  <a:srgbClr val="FFFFFF"/>
+                </a:highlight>
+              </a:rPr>
+              <a:t>string </a:t>
+            </a:r>
+            <a:r>
+              <a:rPr lang="nl-NL" sz="2800" b="0" dirty="0">
+                <a:solidFill>
+                  <a:srgbClr val="000000"/>
+                </a:solidFill>
+                <a:highlight>
+                  <a:srgbClr val="FFFFFF"/>
+                </a:highlight>
+              </a:rPr>
+              <a:t>longWord</a:t>
             </a:r>
             <a:r>
               <a:rPr lang="nl-NL" sz="2800" b="1" dirty="0">
@@ -5299,7 +5450,7 @@
                   <a:srgbClr val="FFFFFF"/>
                 </a:highlight>
               </a:rPr>
-              <a:t>(</a:t>
+              <a:t>,</a:t>
             </a:r>
             <a:r>
               <a:rPr lang="nl-NL" sz="2800" b="0" dirty="0">
@@ -5310,7 +5461,40 @@
                   <a:srgbClr val="FFFFFF"/>
                 </a:highlight>
               </a:rPr>
-              <a:t>string longWord</a:t>
+              <a:t> </a:t>
+            </a:r>
+            <a:r>
+              <a:rPr lang="nl-NL" sz="2800" b="0">
+                <a:solidFill>
+                  <a:srgbClr val="8000FF"/>
+                </a:solidFill>
+                <a:highlight>
+                  <a:srgbClr val="FFFFFF"/>
+                </a:highlight>
+              </a:rPr>
+              <a:t>int</a:t>
+            </a:r>
+            <a:r>
+              <a:rPr lang="nl-NL" sz="2800" b="0">
+                <a:solidFill>
+                  <a:srgbClr val="000000"/>
+                </a:solidFill>
+                <a:highlight>
+                  <a:srgbClr val="FFFFFF"/>
+                </a:highlight>
+              </a:rPr>
+              <a:t> index </a:t>
+            </a:r>
+            <a:r>
+              <a:rPr lang="nl-NL" sz="2800" b="1">
+                <a:solidFill>
+                  <a:srgbClr val="000080"/>
+                </a:solidFill>
+                <a:highlight>
+                  <a:srgbClr val="FFFFFF"/>
+                </a:highlight>
+              </a:rPr>
+              <a:t>) {</a:t>
             </a:r>
             <a:r>
               <a:rPr lang="nl-NL" sz="2800" b="1" dirty="0">
@@ -5321,51 +5505,7 @@
                   <a:srgbClr val="FFFFFF"/>
                 </a:highlight>
               </a:rPr>
-              <a:t>,</a:t>
-            </a:r>
-            <a:r>
-              <a:rPr lang="nl-NL" sz="2800" b="0" dirty="0">
-                <a:solidFill>
-                  <a:srgbClr val="000000"/>
-                </a:solidFill>
-                <a:highlight>
-                  <a:srgbClr val="FFFFFF"/>
-                </a:highlight>
-              </a:rPr>
-              <a:t> </a:t>
-            </a:r>
-            <a:r>
-              <a:rPr lang="nl-NL" sz="2800" b="0" dirty="0">
-                <a:solidFill>
-                  <a:srgbClr val="8000FF"/>
-                </a:solidFill>
-                <a:highlight>
-                  <a:srgbClr val="FFFFFF"/>
-                </a:highlight>
-              </a:rPr>
-              <a:t>int</a:t>
-            </a:r>
-            <a:r>
-              <a:rPr lang="nl-NL" sz="2800" b="0" dirty="0">
-                <a:solidFill>
-                  <a:srgbClr val="000000"/>
-                </a:solidFill>
-                <a:highlight>
-                  <a:srgbClr val="FFFFFF"/>
-                </a:highlight>
-              </a:rPr>
-              <a:t> index</a:t>
-            </a:r>
-            <a:r>
-              <a:rPr lang="nl-NL" sz="2800" b="1" dirty="0">
-                <a:solidFill>
-                  <a:srgbClr val="000080"/>
-                </a:solidFill>
-                <a:highlight>
-                  <a:srgbClr val="FFFFFF"/>
-                </a:highlight>
-              </a:rPr>
-              <a:t>){		</a:t>
+              <a:t>	</a:t>
             </a:r>
             <a:r>
               <a:rPr lang="nl-NL" sz="2800" b="1" dirty="0">
@@ -5686,10 +5826,21 @@
                   <a:srgbClr val="FFFFFF"/>
                 </a:highlight>
               </a:rPr>
-              <a:t> verdubbel</a:t>
-            </a:r>
-            <a:r>
-              <a:rPr lang="nl-NL" sz="2800" b="1" dirty="0">
+              <a:t> </a:t>
+            </a:r>
+            <a:r>
+              <a:rPr lang="nl-NL" sz="2800">
+                <a:solidFill>
+                  <a:srgbClr val="000000"/>
+                </a:solidFill>
+                <a:highlight>
+                  <a:srgbClr val="FFFFFF"/>
+                </a:highlight>
+              </a:rPr>
+              <a:t>verdubbel</a:t>
+            </a:r>
+            <a:r>
+              <a:rPr lang="nl-NL" sz="2800" b="1">
                 <a:solidFill>
                   <a:srgbClr val="000080"/>
                 </a:solidFill>
@@ -5697,10 +5848,10 @@
                   <a:srgbClr val="FFFFFF"/>
                 </a:highlight>
               </a:rPr>
-              <a:t>(</a:t>
-            </a:r>
-            <a:r>
-              <a:rPr lang="nl-NL" dirty="0">
+              <a:t>( </a:t>
+            </a:r>
+            <a:r>
+              <a:rPr lang="nl-NL">
                 <a:solidFill>
                   <a:srgbClr val="8000FF"/>
                 </a:solidFill>
@@ -5711,7 +5862,7 @@
               <a:t>int </a:t>
             </a:r>
             <a:r>
-              <a:rPr lang="nl-NL" sz="2800" b="0" dirty="0">
+              <a:rPr lang="nl-NL" sz="2800" b="0">
                 <a:solidFill>
                   <a:srgbClr val="000000"/>
                 </a:solidFill>
@@ -5719,10 +5870,10 @@
                   <a:srgbClr val="FFFFFF"/>
                 </a:highlight>
               </a:rPr>
-              <a:t>getal</a:t>
-            </a:r>
-            <a:r>
-              <a:rPr lang="nl-NL" sz="2800" b="1" dirty="0">
+              <a:t>getal </a:t>
+            </a:r>
+            <a:r>
+              <a:rPr lang="nl-NL" sz="2800" b="1">
                 <a:solidFill>
                   <a:srgbClr val="000080"/>
                 </a:solidFill>
@@ -5730,7 +5881,7 @@
                   <a:srgbClr val="FFFFFF"/>
                 </a:highlight>
               </a:rPr>
-              <a:t>){</a:t>
+              <a:t>) {</a:t>
             </a:r>
             <a:endParaRPr lang="nl-NL" sz="2800" b="0" dirty="0">
               <a:solidFill>
@@ -5746,7 +5897,7 @@
               <a:buNone/>
             </a:pPr>
             <a:r>
-              <a:rPr lang="nl-NL" sz="2800" b="0" dirty="0">
+              <a:rPr lang="nl-NL" sz="2800" b="0">
                 <a:solidFill>
                   <a:srgbClr val="000000"/>
                 </a:solidFill>
@@ -5754,10 +5905,10 @@
                   <a:srgbClr val="FFFFFF"/>
                 </a:highlight>
               </a:rPr>
-              <a:t>	getal</a:t>
-            </a:r>
-            <a:r>
-              <a:rPr lang="nl-NL" sz="2800" b="1" dirty="0">
+              <a:t>	getal </a:t>
+            </a:r>
+            <a:r>
+              <a:rPr lang="nl-NL" sz="2800" b="1">
                 <a:solidFill>
                   <a:srgbClr val="000080"/>
                 </a:solidFill>
@@ -5765,10 +5916,10 @@
                   <a:srgbClr val="FFFFFF"/>
                 </a:highlight>
               </a:rPr>
-              <a:t>*=</a:t>
-            </a:r>
-            <a:r>
-              <a:rPr lang="nl-NL" sz="2800" b="0" dirty="0">
+              <a:t>*= </a:t>
+            </a:r>
+            <a:r>
+              <a:rPr lang="nl-NL" sz="2800" b="0">
                 <a:solidFill>
                   <a:srgbClr val="FF8000"/>
                 </a:solidFill>
@@ -5835,10 +5986,21 @@
                   <a:srgbClr val="FFFFFF"/>
                 </a:highlight>
               </a:rPr>
-              <a:t> main</a:t>
-            </a:r>
-            <a:r>
-              <a:rPr lang="nl-NL" sz="2800" b="1" dirty="0">
+              <a:t> </a:t>
+            </a:r>
+            <a:r>
+              <a:rPr lang="nl-NL" sz="2800" b="0">
+                <a:solidFill>
+                  <a:srgbClr val="000000"/>
+                </a:solidFill>
+                <a:highlight>
+                  <a:srgbClr val="FFFFFF"/>
+                </a:highlight>
+              </a:rPr>
+              <a:t>main</a:t>
+            </a:r>
+            <a:r>
+              <a:rPr lang="nl-NL" sz="2800" b="1">
                 <a:solidFill>
                   <a:srgbClr val="000080"/>
                 </a:solidFill>
@@ -5846,7 +6008,7 @@
                   <a:srgbClr val="FFFFFF"/>
                 </a:highlight>
               </a:rPr>
-              <a:t>(){</a:t>
+              <a:t>() {</a:t>
             </a:r>
             <a:endParaRPr lang="nl-NL" sz="2800" b="0" dirty="0">
               <a:solidFill>
@@ -5895,7 +6057,7 @@
               <a:t> nummer </a:t>
             </a:r>
             <a:r>
-              <a:rPr lang="nl-NL" sz="2800" b="1" dirty="0">
+              <a:rPr lang="nl-NL" sz="2800" b="1">
                 <a:solidFill>
                   <a:srgbClr val="000080"/>
                 </a:solidFill>
@@ -5906,7 +6068,7 @@
               <a:t>=</a:t>
             </a:r>
             <a:r>
-              <a:rPr lang="nl-NL" sz="2800" b="0" dirty="0">
+              <a:rPr lang="nl-NL" sz="2800" b="0">
                 <a:solidFill>
                   <a:srgbClr val="000000"/>
                 </a:solidFill>
@@ -5917,7 +6079,7 @@
               <a:t> </a:t>
             </a:r>
             <a:r>
-              <a:rPr lang="nl-NL" sz="2800" b="0" dirty="0">
+              <a:rPr lang="nl-NL" sz="2800" b="0">
                 <a:solidFill>
                   <a:srgbClr val="FF8000"/>
                 </a:solidFill>
@@ -5927,7 +6089,18 @@
               </a:rPr>
               <a:t>3</a:t>
             </a:r>
-            <a:endParaRPr lang="nl-NL" sz="2800" b="0" dirty="0">
+            <a:r>
+              <a:rPr lang="nl-NL" b="1">
+                <a:solidFill>
+                  <a:srgbClr val="000080"/>
+                </a:solidFill>
+                <a:highlight>
+                  <a:srgbClr val="FFFFFF"/>
+                </a:highlight>
+              </a:rPr>
+              <a:t>;</a:t>
+            </a:r>
+            <a:endParaRPr lang="nl-NL">
               <a:solidFill>
                 <a:srgbClr val="000000"/>
               </a:solidFill>
@@ -6600,10 +6773,21 @@
                   <a:srgbClr val="FFFFFF"/>
                 </a:highlight>
               </a:rPr>
-              <a:t> verdubbel</a:t>
-            </a:r>
-            <a:r>
-              <a:rPr lang="nl-NL" sz="2800" b="1" dirty="0">
+              <a:t> </a:t>
+            </a:r>
+            <a:r>
+              <a:rPr lang="nl-NL" sz="2800">
+                <a:solidFill>
+                  <a:srgbClr val="000000"/>
+                </a:solidFill>
+                <a:highlight>
+                  <a:srgbClr val="FFFFFF"/>
+                </a:highlight>
+              </a:rPr>
+              <a:t>verdubbel</a:t>
+            </a:r>
+            <a:r>
+              <a:rPr lang="nl-NL" sz="2800" b="1">
                 <a:solidFill>
                   <a:srgbClr val="000080"/>
                 </a:solidFill>
@@ -6611,10 +6795,10 @@
                   <a:srgbClr val="FFFFFF"/>
                 </a:highlight>
               </a:rPr>
-              <a:t>(</a:t>
-            </a:r>
-            <a:r>
-              <a:rPr lang="nl-NL" dirty="0">
+              <a:t>( </a:t>
+            </a:r>
+            <a:r>
+              <a:rPr lang="nl-NL">
                 <a:solidFill>
                   <a:srgbClr val="8000FF"/>
                 </a:solidFill>
@@ -6625,7 +6809,7 @@
               <a:t>int </a:t>
             </a:r>
             <a:r>
-              <a:rPr lang="nl-NL" sz="2800" b="0" dirty="0">
+              <a:rPr lang="nl-NL" sz="2800" b="0">
                 <a:solidFill>
                   <a:srgbClr val="000000"/>
                 </a:solidFill>
@@ -6633,10 +6817,10 @@
                   <a:srgbClr val="FFFFFF"/>
                 </a:highlight>
               </a:rPr>
-              <a:t>getal</a:t>
-            </a:r>
-            <a:r>
-              <a:rPr lang="nl-NL" sz="2800" b="1" dirty="0">
+              <a:t>getal </a:t>
+            </a:r>
+            <a:r>
+              <a:rPr lang="nl-NL" sz="2800" b="1">
                 <a:solidFill>
                   <a:srgbClr val="000080"/>
                 </a:solidFill>
@@ -6644,7 +6828,7 @@
                   <a:srgbClr val="FFFFFF"/>
                 </a:highlight>
               </a:rPr>
-              <a:t>){</a:t>
+              <a:t>) {</a:t>
             </a:r>
             <a:endParaRPr lang="nl-NL" sz="2800" b="0" dirty="0">
               <a:solidFill>
@@ -6668,10 +6852,21 @@
                   <a:srgbClr val="FFFFFF"/>
                 </a:highlight>
               </a:rPr>
-              <a:t>	return getal</a:t>
-            </a:r>
-            <a:r>
-              <a:rPr lang="nl-NL" sz="2800" b="1" dirty="0">
+              <a:t>	</a:t>
+            </a:r>
+            <a:r>
+              <a:rPr lang="nl-NL" sz="2800" b="0">
+                <a:solidFill>
+                  <a:srgbClr val="000000"/>
+                </a:solidFill>
+                <a:highlight>
+                  <a:srgbClr val="FFFFFF"/>
+                </a:highlight>
+              </a:rPr>
+              <a:t>return getal </a:t>
+            </a:r>
+            <a:r>
+              <a:rPr lang="nl-NL" sz="2800" b="1">
                 <a:solidFill>
                   <a:srgbClr val="000080"/>
                 </a:solidFill>
@@ -6679,10 +6874,10 @@
                   <a:srgbClr val="FFFFFF"/>
                 </a:highlight>
               </a:rPr>
-              <a:t>*=</a:t>
-            </a:r>
-            <a:r>
-              <a:rPr lang="nl-NL" sz="2800" b="0" dirty="0">
+              <a:t>*= </a:t>
+            </a:r>
+            <a:r>
+              <a:rPr lang="nl-NL" sz="2800" b="0">
                 <a:solidFill>
                   <a:srgbClr val="FF8000"/>
                 </a:solidFill>
@@ -6749,10 +6944,21 @@
                   <a:srgbClr val="FFFFFF"/>
                 </a:highlight>
               </a:rPr>
-              <a:t> main</a:t>
-            </a:r>
-            <a:r>
-              <a:rPr lang="nl-NL" sz="2800" b="1" dirty="0">
+              <a:t> </a:t>
+            </a:r>
+            <a:r>
+              <a:rPr lang="nl-NL" sz="2800" b="0">
+                <a:solidFill>
+                  <a:srgbClr val="000000"/>
+                </a:solidFill>
+                <a:highlight>
+                  <a:srgbClr val="FFFFFF"/>
+                </a:highlight>
+              </a:rPr>
+              <a:t>main</a:t>
+            </a:r>
+            <a:r>
+              <a:rPr lang="nl-NL" sz="2800" b="1">
                 <a:solidFill>
                   <a:srgbClr val="000080"/>
                 </a:solidFill>
@@ -6760,7 +6966,7 @@
                   <a:srgbClr val="FFFFFF"/>
                 </a:highlight>
               </a:rPr>
-              <a:t>(){</a:t>
+              <a:t>() {</a:t>
             </a:r>
             <a:endParaRPr lang="nl-NL" sz="2800" b="0" dirty="0">
               <a:solidFill>
@@ -6863,10 +7069,21 @@
                   <a:srgbClr val="FFFFFF"/>
                 </a:highlight>
               </a:rPr>
-              <a:t>	nummer = verdubbel</a:t>
-            </a:r>
-            <a:r>
-              <a:rPr lang="nl-NL" sz="2800" b="1" dirty="0">
+              <a:t>	nummer = </a:t>
+            </a:r>
+            <a:r>
+              <a:rPr lang="nl-NL" sz="2800" b="0">
+                <a:solidFill>
+                  <a:srgbClr val="000000"/>
+                </a:solidFill>
+                <a:highlight>
+                  <a:srgbClr val="FFFFFF"/>
+                </a:highlight>
+              </a:rPr>
+              <a:t>verdubbel</a:t>
+            </a:r>
+            <a:r>
+              <a:rPr lang="nl-NL" sz="2800" b="1">
                 <a:solidFill>
                   <a:srgbClr val="000080"/>
                 </a:solidFill>
@@ -6877,7 +7094,7 @@
               <a:t>(</a:t>
             </a:r>
             <a:r>
-              <a:rPr lang="nl-NL" sz="2800" b="0" dirty="0">
+              <a:rPr lang="nl-NL" sz="2800" b="0">
                 <a:solidFill>
                   <a:srgbClr val="000000"/>
                 </a:solidFill>
@@ -7349,10 +7566,21 @@
                   <a:srgbClr val="FFFFFF"/>
                 </a:highlight>
               </a:rPr>
-              <a:t> verdubbel</a:t>
-            </a:r>
-            <a:r>
-              <a:rPr lang="nl-NL" sz="2800" b="1" dirty="0">
+              <a:t> </a:t>
+            </a:r>
+            <a:r>
+              <a:rPr lang="nl-NL" sz="2800">
+                <a:solidFill>
+                  <a:srgbClr val="000000"/>
+                </a:solidFill>
+                <a:highlight>
+                  <a:srgbClr val="FFFFFF"/>
+                </a:highlight>
+              </a:rPr>
+              <a:t>verdubbel</a:t>
+            </a:r>
+            <a:r>
+              <a:rPr lang="nl-NL" sz="2800" b="1">
                 <a:solidFill>
                   <a:srgbClr val="000080"/>
                 </a:solidFill>
@@ -7360,10 +7588,10 @@
                   <a:srgbClr val="FFFFFF"/>
                 </a:highlight>
               </a:rPr>
-              <a:t>(</a:t>
-            </a:r>
-            <a:r>
-              <a:rPr lang="nl-NL" dirty="0">
+              <a:t>( </a:t>
+            </a:r>
+            <a:r>
+              <a:rPr lang="nl-NL">
                 <a:solidFill>
                   <a:srgbClr val="8000FF"/>
                 </a:solidFill>
@@ -7374,7 +7602,7 @@
               <a:t>int </a:t>
             </a:r>
             <a:r>
-              <a:rPr lang="nl-NL" sz="2800" b="0" dirty="0">
+              <a:rPr lang="nl-NL" sz="2800" b="0">
                 <a:solidFill>
                   <a:srgbClr val="000000"/>
                 </a:solidFill>
@@ -7382,10 +7610,10 @@
                   <a:srgbClr val="FFFFFF"/>
                 </a:highlight>
               </a:rPr>
-              <a:t>getal</a:t>
-            </a:r>
-            <a:r>
-              <a:rPr lang="nl-NL" sz="2800" b="1" dirty="0">
+              <a:t>getal </a:t>
+            </a:r>
+            <a:r>
+              <a:rPr lang="nl-NL" sz="2800" b="1">
                 <a:solidFill>
                   <a:srgbClr val="000080"/>
                 </a:solidFill>
@@ -7393,7 +7621,7 @@
                   <a:srgbClr val="FFFFFF"/>
                 </a:highlight>
               </a:rPr>
-              <a:t>){</a:t>
+              <a:t>) {</a:t>
             </a:r>
             <a:endParaRPr lang="nl-NL" sz="2800" b="0" dirty="0">
               <a:solidFill>
@@ -7498,10 +7726,21 @@
                   <a:srgbClr val="FFFFFF"/>
                 </a:highlight>
               </a:rPr>
-              <a:t> main</a:t>
-            </a:r>
-            <a:r>
-              <a:rPr lang="nl-NL" sz="2800" b="1" dirty="0">
+              <a:t> </a:t>
+            </a:r>
+            <a:r>
+              <a:rPr lang="nl-NL" sz="2800" b="0">
+                <a:solidFill>
+                  <a:srgbClr val="000000"/>
+                </a:solidFill>
+                <a:highlight>
+                  <a:srgbClr val="FFFFFF"/>
+                </a:highlight>
+              </a:rPr>
+              <a:t>main</a:t>
+            </a:r>
+            <a:r>
+              <a:rPr lang="nl-NL" sz="2800" b="1">
                 <a:solidFill>
                   <a:srgbClr val="000080"/>
                 </a:solidFill>
@@ -7509,7 +7748,7 @@
                   <a:srgbClr val="FFFFFF"/>
                 </a:highlight>
               </a:rPr>
-              <a:t>(){</a:t>
+              <a:t>() {</a:t>
             </a:r>
             <a:endParaRPr lang="nl-NL" sz="2800" b="0" dirty="0">
               <a:solidFill>
@@ -8338,10 +8577,21 @@
                   <a:srgbClr val="FFFFFF"/>
                 </a:highlight>
               </a:rPr>
-              <a:t> verdubbel</a:t>
-            </a:r>
-            <a:r>
-              <a:rPr lang="nl-NL" sz="2800" b="1" dirty="0">
+              <a:t> </a:t>
+            </a:r>
+            <a:r>
+              <a:rPr lang="nl-NL" sz="2800">
+                <a:solidFill>
+                  <a:srgbClr val="000000"/>
+                </a:solidFill>
+                <a:highlight>
+                  <a:srgbClr val="FFFFFF"/>
+                </a:highlight>
+              </a:rPr>
+              <a:t>verdubbel</a:t>
+            </a:r>
+            <a:r>
+              <a:rPr lang="nl-NL" sz="2800" b="1">
                 <a:solidFill>
                   <a:srgbClr val="000080"/>
                 </a:solidFill>
@@ -8349,10 +8599,10 @@
                   <a:srgbClr val="FFFFFF"/>
                 </a:highlight>
               </a:rPr>
-              <a:t>(</a:t>
-            </a:r>
-            <a:r>
-              <a:rPr lang="nl-NL" dirty="0">
+              <a:t>( </a:t>
+            </a:r>
+            <a:r>
+              <a:rPr lang="nl-NL">
                 <a:solidFill>
                   <a:srgbClr val="8000FF"/>
                 </a:solidFill>
@@ -8363,7 +8613,7 @@
               <a:t>int </a:t>
             </a:r>
             <a:r>
-              <a:rPr lang="nl-NL" sz="2800" b="0" dirty="0">
+              <a:rPr lang="nl-NL" sz="2800" b="0">
                 <a:solidFill>
                   <a:srgbClr val="000000"/>
                 </a:solidFill>
@@ -8371,10 +8621,10 @@
                   <a:srgbClr val="FFFFFF"/>
                 </a:highlight>
               </a:rPr>
-              <a:t>getal</a:t>
-            </a:r>
-            <a:r>
-              <a:rPr lang="nl-NL" sz="2800" b="1" dirty="0">
+              <a:t>getal </a:t>
+            </a:r>
+            <a:r>
+              <a:rPr lang="nl-NL" sz="2800" b="1">
                 <a:solidFill>
                   <a:srgbClr val="000080"/>
                 </a:solidFill>
@@ -8382,7 +8632,7 @@
                   <a:srgbClr val="FFFFFF"/>
                 </a:highlight>
               </a:rPr>
-              <a:t>){</a:t>
+              <a:t>) {</a:t>
             </a:r>
             <a:endParaRPr lang="nl-NL" sz="2800" b="0" dirty="0">
               <a:solidFill>
@@ -8406,10 +8656,21 @@
                   <a:srgbClr val="FFFFFF"/>
                 </a:highlight>
               </a:rPr>
-              <a:t>	return getal</a:t>
-            </a:r>
-            <a:r>
-              <a:rPr lang="nl-NL" sz="2800" b="1" dirty="0">
+              <a:t>	</a:t>
+            </a:r>
+            <a:r>
+              <a:rPr lang="nl-NL" sz="2800" b="0">
+                <a:solidFill>
+                  <a:srgbClr val="000000"/>
+                </a:solidFill>
+                <a:highlight>
+                  <a:srgbClr val="FFFFFF"/>
+                </a:highlight>
+              </a:rPr>
+              <a:t>return getal </a:t>
+            </a:r>
+            <a:r>
+              <a:rPr lang="nl-NL" sz="2800" b="1">
                 <a:solidFill>
                   <a:srgbClr val="000080"/>
                 </a:solidFill>
@@ -8417,10 +8678,10 @@
                   <a:srgbClr val="FFFFFF"/>
                 </a:highlight>
               </a:rPr>
-              <a:t>*=</a:t>
-            </a:r>
-            <a:r>
-              <a:rPr lang="nl-NL" sz="2800" b="0" dirty="0">
+              <a:t>*= </a:t>
+            </a:r>
+            <a:r>
+              <a:rPr lang="nl-NL" sz="2800" b="0">
                 <a:solidFill>
                   <a:srgbClr val="FF8000"/>
                 </a:solidFill>
@@ -8487,10 +8748,21 @@
                   <a:srgbClr val="FFFFFF"/>
                 </a:highlight>
               </a:rPr>
-              <a:t> main</a:t>
-            </a:r>
-            <a:r>
-              <a:rPr lang="nl-NL" sz="2800" b="1" dirty="0">
+              <a:t> </a:t>
+            </a:r>
+            <a:r>
+              <a:rPr lang="nl-NL" sz="2800" b="0">
+                <a:solidFill>
+                  <a:srgbClr val="000000"/>
+                </a:solidFill>
+                <a:highlight>
+                  <a:srgbClr val="FFFFFF"/>
+                </a:highlight>
+              </a:rPr>
+              <a:t>main</a:t>
+            </a:r>
+            <a:r>
+              <a:rPr lang="nl-NL" sz="2800" b="1">
                 <a:solidFill>
                   <a:srgbClr val="000080"/>
                 </a:solidFill>
@@ -8498,7 +8770,7 @@
                   <a:srgbClr val="FFFFFF"/>
                 </a:highlight>
               </a:rPr>
-              <a:t>(){</a:t>
+              <a:t>() {</a:t>
             </a:r>
             <a:endParaRPr lang="nl-NL" sz="2800" b="0" dirty="0">
               <a:solidFill>
@@ -9087,10 +9359,21 @@
                   <a:srgbClr val="FFFFFF"/>
                 </a:highlight>
               </a:rPr>
-              <a:t> verdubbel</a:t>
-            </a:r>
-            <a:r>
-              <a:rPr lang="nl-NL" sz="2800" b="1" dirty="0">
+              <a:t> </a:t>
+            </a:r>
+            <a:r>
+              <a:rPr lang="nl-NL" sz="2800">
+                <a:solidFill>
+                  <a:srgbClr val="000000"/>
+                </a:solidFill>
+                <a:highlight>
+                  <a:srgbClr val="FFFFFF"/>
+                </a:highlight>
+              </a:rPr>
+              <a:t>verdubbel</a:t>
+            </a:r>
+            <a:r>
+              <a:rPr lang="nl-NL" sz="2800" b="1">
                 <a:solidFill>
                   <a:srgbClr val="000080"/>
                 </a:solidFill>
@@ -9098,10 +9381,10 @@
                   <a:srgbClr val="FFFFFF"/>
                 </a:highlight>
               </a:rPr>
-              <a:t>(</a:t>
-            </a:r>
-            <a:r>
-              <a:rPr lang="nl-NL" dirty="0">
+              <a:t>( </a:t>
+            </a:r>
+            <a:r>
+              <a:rPr lang="nl-NL">
                 <a:solidFill>
                   <a:srgbClr val="8000FF"/>
                 </a:solidFill>
@@ -9112,7 +9395,7 @@
               <a:t>int </a:t>
             </a:r>
             <a:r>
-              <a:rPr lang="nl-NL" sz="2800" b="0" dirty="0">
+              <a:rPr lang="nl-NL" sz="2800" b="0">
                 <a:solidFill>
                   <a:srgbClr val="000000"/>
                 </a:solidFill>
@@ -9120,10 +9403,10 @@
                   <a:srgbClr val="FFFFFF"/>
                 </a:highlight>
               </a:rPr>
-              <a:t>getal</a:t>
-            </a:r>
-            <a:r>
-              <a:rPr lang="nl-NL" sz="2800" b="1" dirty="0">
+              <a:t>getal </a:t>
+            </a:r>
+            <a:r>
+              <a:rPr lang="nl-NL" sz="2800" b="1">
                 <a:solidFill>
                   <a:srgbClr val="000080"/>
                 </a:solidFill>
@@ -9131,7 +9414,7 @@
                   <a:srgbClr val="FFFFFF"/>
                 </a:highlight>
               </a:rPr>
-              <a:t>){</a:t>
+              <a:t>) {</a:t>
             </a:r>
             <a:endParaRPr lang="nl-NL" sz="2800" b="0" dirty="0">
               <a:solidFill>
@@ -9222,10 +9505,21 @@
                   <a:srgbClr val="FFFFFF"/>
                 </a:highlight>
               </a:rPr>
-              <a:t> main</a:t>
-            </a:r>
-            <a:r>
-              <a:rPr lang="nl-NL" sz="2800" b="1" dirty="0">
+              <a:t> </a:t>
+            </a:r>
+            <a:r>
+              <a:rPr lang="nl-NL" sz="2800" b="0">
+                <a:solidFill>
+                  <a:srgbClr val="000000"/>
+                </a:solidFill>
+                <a:highlight>
+                  <a:srgbClr val="FFFFFF"/>
+                </a:highlight>
+              </a:rPr>
+              <a:t>main</a:t>
+            </a:r>
+            <a:r>
+              <a:rPr lang="nl-NL" sz="2800" b="1">
                 <a:solidFill>
                   <a:srgbClr val="000080"/>
                 </a:solidFill>
@@ -9233,7 +9527,7 @@
                   <a:srgbClr val="FFFFFF"/>
                 </a:highlight>
               </a:rPr>
-              <a:t>(){</a:t>
+              <a:t>() {</a:t>
             </a:r>
             <a:endParaRPr lang="nl-NL" sz="2800" b="0" dirty="0">
               <a:solidFill>
@@ -9282,7 +9576,7 @@
               <a:t> nummer </a:t>
             </a:r>
             <a:r>
-              <a:rPr lang="nl-NL" sz="2800" b="1" dirty="0">
+              <a:rPr lang="nl-NL" sz="2800" b="1">
                 <a:solidFill>
                   <a:srgbClr val="000080"/>
                 </a:solidFill>
@@ -9293,7 +9587,7 @@
               <a:t>=</a:t>
             </a:r>
             <a:r>
-              <a:rPr lang="nl-NL" sz="2800" b="0" dirty="0">
+              <a:rPr lang="nl-NL" sz="2800" b="0">
                 <a:solidFill>
                   <a:srgbClr val="000000"/>
                 </a:solidFill>
@@ -9304,7 +9598,7 @@
               <a:t> </a:t>
             </a:r>
             <a:r>
-              <a:rPr lang="nl-NL" sz="2800" b="0" dirty="0">
+              <a:rPr lang="nl-NL" sz="2800" b="0">
                 <a:solidFill>
                   <a:srgbClr val="FF8000"/>
                 </a:solidFill>
@@ -9313,6 +9607,17 @@
                 </a:highlight>
               </a:rPr>
               <a:t>3</a:t>
+            </a:r>
+            <a:r>
+              <a:rPr lang="nl-NL" b="1">
+                <a:solidFill>
+                  <a:srgbClr val="000080"/>
+                </a:solidFill>
+                <a:highlight>
+                  <a:srgbClr val="FFFFFF"/>
+                </a:highlight>
+              </a:rPr>
+              <a:t>;</a:t>
             </a:r>
             <a:endParaRPr lang="nl-NL" sz="2800" b="0" dirty="0">
               <a:solidFill>
@@ -9789,7 +10094,9 @@
         </p:nvSpPr>
         <p:spPr/>
         <p:txBody>
-          <a:bodyPr/>
+          <a:bodyPr>
+            <a:normAutofit/>
+          </a:bodyPr>
           <a:lstStyle/>
           <a:p>
             <a:pPr marL="0" indent="0">
@@ -9815,10 +10122,21 @@
                   <a:srgbClr val="FFFFFF"/>
                 </a:highlight>
               </a:rPr>
-              <a:t> verdubbel</a:t>
-            </a:r>
-            <a:r>
-              <a:rPr lang="nl-NL" sz="2800" b="1" dirty="0">
+              <a:t> </a:t>
+            </a:r>
+            <a:r>
+              <a:rPr lang="nl-NL" sz="2800">
+                <a:solidFill>
+                  <a:srgbClr val="000000"/>
+                </a:solidFill>
+                <a:highlight>
+                  <a:srgbClr val="FFFFFF"/>
+                </a:highlight>
+              </a:rPr>
+              <a:t>verdubbel</a:t>
+            </a:r>
+            <a:r>
+              <a:rPr lang="nl-NL" sz="2800" b="1">
                 <a:solidFill>
                   <a:srgbClr val="000080"/>
                 </a:solidFill>
@@ -9826,10 +10144,10 @@
                   <a:srgbClr val="FFFFFF"/>
                 </a:highlight>
               </a:rPr>
-              <a:t>(</a:t>
-            </a:r>
-            <a:r>
-              <a:rPr lang="nl-NL" sz="2800" b="0" dirty="0">
+              <a:t>( </a:t>
+            </a:r>
+            <a:r>
+              <a:rPr lang="nl-NL" sz="2800" b="0">
                 <a:solidFill>
                   <a:srgbClr val="8000FF"/>
                 </a:solidFill>
@@ -9840,7 +10158,7 @@
               <a:t>int</a:t>
             </a:r>
             <a:r>
-              <a:rPr lang="nl-NL" sz="2800" b="1" dirty="0">
+              <a:rPr lang="nl-NL" sz="2800" b="1">
                 <a:solidFill>
                   <a:srgbClr val="000080"/>
                 </a:solidFill>
@@ -9851,7 +10169,7 @@
               <a:t>&amp;</a:t>
             </a:r>
             <a:r>
-              <a:rPr lang="nl-NL" sz="2800" b="0" dirty="0">
+              <a:rPr lang="nl-NL" sz="2800" b="0">
                 <a:solidFill>
                   <a:srgbClr val="000000"/>
                 </a:solidFill>
@@ -9859,10 +10177,10 @@
                   <a:srgbClr val="FFFFFF"/>
                 </a:highlight>
               </a:rPr>
-              <a:t> getal</a:t>
-            </a:r>
-            <a:r>
-              <a:rPr lang="nl-NL" sz="2800" b="1" dirty="0">
+              <a:t> getal </a:t>
+            </a:r>
+            <a:r>
+              <a:rPr lang="nl-NL" sz="2800" b="1">
                 <a:solidFill>
                   <a:srgbClr val="000080"/>
                 </a:solidFill>
@@ -9886,7 +10204,7 @@
               <a:buNone/>
             </a:pPr>
             <a:r>
-              <a:rPr lang="nl-NL" sz="2800" b="0" dirty="0">
+              <a:rPr lang="nl-NL" sz="2800" b="0">
                 <a:solidFill>
                   <a:srgbClr val="000000"/>
                 </a:solidFill>
@@ -9894,10 +10212,10 @@
                   <a:srgbClr val="FFFFFF"/>
                 </a:highlight>
               </a:rPr>
-              <a:t>	getal</a:t>
-            </a:r>
-            <a:r>
-              <a:rPr lang="nl-NL" sz="2800" b="1" dirty="0">
+              <a:t>	getal </a:t>
+            </a:r>
+            <a:r>
+              <a:rPr lang="nl-NL" sz="2800" b="1">
                 <a:solidFill>
                   <a:srgbClr val="000080"/>
                 </a:solidFill>
@@ -9905,10 +10223,10 @@
                   <a:srgbClr val="FFFFFF"/>
                 </a:highlight>
               </a:rPr>
-              <a:t>*=</a:t>
-            </a:r>
-            <a:r>
-              <a:rPr lang="nl-NL" sz="2800" b="0" dirty="0">
+              <a:t>*= </a:t>
+            </a:r>
+            <a:r>
+              <a:rPr lang="nl-NL" sz="2800" b="0">
                 <a:solidFill>
                   <a:srgbClr val="FF8000"/>
                 </a:solidFill>
@@ -10035,7 +10353,7 @@
               <a:t> nummer </a:t>
             </a:r>
             <a:r>
-              <a:rPr lang="nl-NL" sz="2800" b="1" dirty="0">
+              <a:rPr lang="nl-NL" sz="2800" b="1">
                 <a:solidFill>
                   <a:srgbClr val="000080"/>
                 </a:solidFill>
@@ -10046,7 +10364,7 @@
               <a:t>=</a:t>
             </a:r>
             <a:r>
-              <a:rPr lang="nl-NL" sz="2800" b="0" dirty="0">
+              <a:rPr lang="nl-NL" sz="2800" b="0">
                 <a:solidFill>
                   <a:srgbClr val="000000"/>
                 </a:solidFill>
@@ -10057,7 +10375,7 @@
               <a:t> </a:t>
             </a:r>
             <a:r>
-              <a:rPr lang="nl-NL" sz="2800" b="0" dirty="0">
+              <a:rPr lang="nl-NL" sz="2800" b="0">
                 <a:solidFill>
                   <a:srgbClr val="FF8000"/>
                 </a:solidFill>
@@ -10066,6 +10384,17 @@
                 </a:highlight>
               </a:rPr>
               <a:t>3</a:t>
+            </a:r>
+            <a:r>
+              <a:rPr lang="nl-NL" b="1">
+                <a:solidFill>
+                  <a:srgbClr val="000080"/>
+                </a:solidFill>
+                <a:highlight>
+                  <a:srgbClr val="FFFFFF"/>
+                </a:highlight>
+              </a:rPr>
+              <a:t>;</a:t>
             </a:r>
             <a:endParaRPr lang="nl-NL" sz="2800" b="0" dirty="0">
               <a:solidFill>
@@ -10669,10 +10998,21 @@
                   <a:srgbClr val="FFFFFF"/>
                 </a:highlight>
               </a:rPr>
-              <a:t> func</a:t>
-            </a:r>
-            <a:r>
-              <a:rPr lang="nl-NL" sz="2400" b="1" dirty="0">
+              <a:t> </a:t>
+            </a:r>
+            <a:r>
+              <a:rPr lang="nl-NL" sz="2400">
+                <a:solidFill>
+                  <a:srgbClr val="000000"/>
+                </a:solidFill>
+                <a:highlight>
+                  <a:srgbClr val="FFFFFF"/>
+                </a:highlight>
+              </a:rPr>
+              <a:t>func</a:t>
+            </a:r>
+            <a:r>
+              <a:rPr lang="nl-NL" sz="2400" b="1">
                 <a:solidFill>
                   <a:srgbClr val="000080"/>
                 </a:solidFill>
@@ -10680,10 +11020,10 @@
                   <a:srgbClr val="FFFFFF"/>
                 </a:highlight>
               </a:rPr>
-              <a:t>(</a:t>
-            </a:r>
-            <a:r>
-              <a:rPr lang="nl-NL" sz="2400" b="0" dirty="0">
+              <a:t>( </a:t>
+            </a:r>
+            <a:r>
+              <a:rPr lang="nl-NL" sz="2400" b="0">
                 <a:solidFill>
                   <a:srgbClr val="8000FF"/>
                 </a:solidFill>
@@ -10694,7 +11034,7 @@
               <a:t>int</a:t>
             </a:r>
             <a:r>
-              <a:rPr lang="nl-NL" sz="2400" b="1" dirty="0">
+              <a:rPr lang="nl-NL" sz="2400" b="1">
                 <a:solidFill>
                   <a:srgbClr val="000080"/>
                 </a:solidFill>
@@ -10705,7 +11045,7 @@
               <a:t>&amp;</a:t>
             </a:r>
             <a:r>
-              <a:rPr lang="nl-NL" sz="2400" b="0" dirty="0">
+              <a:rPr lang="nl-NL" sz="2400" b="0">
                 <a:solidFill>
                   <a:srgbClr val="000000"/>
                 </a:solidFill>
@@ -10713,10 +11053,10 @@
                   <a:srgbClr val="FFFFFF"/>
                 </a:highlight>
               </a:rPr>
-              <a:t> param</a:t>
-            </a:r>
-            <a:r>
-              <a:rPr lang="nl-NL" sz="2400" b="1" dirty="0">
+              <a:t> param </a:t>
+            </a:r>
+            <a:r>
+              <a:rPr lang="nl-NL" sz="2400" b="1">
                 <a:solidFill>
                   <a:srgbClr val="000080"/>
                 </a:solidFill>
@@ -10727,7 +11067,7 @@
               <a:t>){</a:t>
             </a:r>
             <a:r>
-              <a:rPr lang="nl-NL" sz="2400" b="0" dirty="0">
+              <a:rPr lang="nl-NL" sz="2400" b="0">
                 <a:solidFill>
                   <a:srgbClr val="000000"/>
                 </a:solidFill>
@@ -10829,10 +11169,21 @@
                   <a:srgbClr val="FFFFFF"/>
                 </a:highlight>
               </a:rPr>
-              <a:t> func</a:t>
-            </a:r>
-            <a:r>
-              <a:rPr lang="nl-NL" b="1" dirty="0">
+              <a:t> </a:t>
+            </a:r>
+            <a:r>
+              <a:rPr lang="nl-NL">
+                <a:solidFill>
+                  <a:srgbClr val="000000"/>
+                </a:solidFill>
+                <a:highlight>
+                  <a:srgbClr val="FFFFFF"/>
+                </a:highlight>
+              </a:rPr>
+              <a:t>func</a:t>
+            </a:r>
+            <a:r>
+              <a:rPr lang="nl-NL" b="1">
                 <a:solidFill>
                   <a:srgbClr val="000080"/>
                 </a:solidFill>
@@ -10840,10 +11191,10 @@
                   <a:srgbClr val="FFFFFF"/>
                 </a:highlight>
               </a:rPr>
-              <a:t>(</a:t>
-            </a:r>
-            <a:r>
-              <a:rPr lang="nl-NL" b="0" dirty="0">
+              <a:t>( </a:t>
+            </a:r>
+            <a:r>
+              <a:rPr lang="nl-NL" b="0">
                 <a:solidFill>
                   <a:srgbClr val="8000FF"/>
                 </a:solidFill>
@@ -10854,7 +11205,7 @@
               <a:t>int</a:t>
             </a:r>
             <a:r>
-              <a:rPr lang="nl-NL" b="0" dirty="0">
+              <a:rPr lang="nl-NL" b="0">
                 <a:solidFill>
                   <a:srgbClr val="000000"/>
                 </a:solidFill>
@@ -10862,10 +11213,10 @@
                   <a:srgbClr val="FFFFFF"/>
                 </a:highlight>
               </a:rPr>
-              <a:t> param</a:t>
-            </a:r>
-            <a:r>
-              <a:rPr lang="nl-NL" b="1" dirty="0">
+              <a:t> param </a:t>
+            </a:r>
+            <a:r>
+              <a:rPr lang="nl-NL" b="1">
                 <a:solidFill>
                   <a:srgbClr val="000080"/>
                 </a:solidFill>
@@ -10876,7 +11227,7 @@
               <a:t>){</a:t>
             </a:r>
             <a:r>
-              <a:rPr lang="nl-NL" b="0" dirty="0">
+              <a:rPr lang="nl-NL" b="0">
                 <a:solidFill>
                   <a:srgbClr val="000000"/>
                 </a:solidFill>
@@ -11131,7 +11482,19 @@
           <a:p>
             <a:r>
               <a:rPr lang="en-US" dirty="0"/>
-              <a:t>Reference 			   vs				       Value</a:t>
+              <a:t>Reference 			</a:t>
+            </a:r>
+            <a:r>
+              <a:rPr lang="en-US"/>
+              <a:t> vs</a:t>
+            </a:r>
+            <a:r>
+              <a:rPr lang="en-US" dirty="0"/>
+              <a:t>	</a:t>
+            </a:r>
+            <a:r>
+              <a:rPr lang="en-US"/>
+              <a:t>	 Value</a:t>
             </a:r>
             <a:endParaRPr lang="en-NL" dirty="0"/>
           </a:p>
@@ -11533,7 +11896,7 @@
         <p:spPr/>
         <p:txBody>
           <a:bodyPr>
-            <a:normAutofit lnSpcReduction="10000"/>
+            <a:normAutofit fontScale="92500" lnSpcReduction="10000"/>
           </a:bodyPr>
           <a:lstStyle/>
           <a:p>
@@ -11550,36 +11913,39 @@
               <a:t> </a:t>
             </a:r>
             <a:r>
-              <a:rPr lang="en-US" dirty="0" err="1"/>
+              <a:rPr lang="en-US" i="1" dirty="0" err="1"/>
               <a:t>groot</a:t>
             </a:r>
             <a:r>
-              <a:rPr lang="en-US" dirty="0"/>
+              <a:rPr lang="en-US" i="1" dirty="0"/>
               <a:t>, </a:t>
             </a:r>
             <a:r>
-              <a:rPr lang="en-US" dirty="0" err="1"/>
+              <a:rPr lang="en-US" i="1" dirty="0" err="1"/>
               <a:t>duur</a:t>
             </a:r>
             <a:r>
-              <a:rPr lang="en-US" dirty="0"/>
+              <a:rPr lang="en-US" i="1" dirty="0"/>
               <a:t> object </a:t>
             </a:r>
             <a:r>
-              <a:rPr lang="en-US" dirty="0" err="1"/>
+              <a:rPr lang="en-US" err="1"/>
               <a:t>gaat</a:t>
             </a:r>
             <a:r>
-              <a:rPr lang="en-US" dirty="0"/>
+              <a:rPr lang="en-US"/>
               <a:t> </a:t>
             </a:r>
-            <a:r>
-              <a:rPr lang="en-US" dirty="0" err="1"/>
-              <a:t>en</a:t>
-            </a:r>
-            <a:r>
-              <a:rPr lang="en-US" dirty="0"/>
-              <a:t> je </a:t>
+            <a:br>
+              <a:rPr lang="en-US"/>
+            </a:br>
+            <a:r>
+              <a:rPr lang="en-US"/>
+              <a:t>en </a:t>
+            </a:r>
+            <a:r>
+              <a:rPr lang="en-US" dirty="0"/>
+              <a:t>je </a:t>
             </a:r>
             <a:r>
               <a:rPr lang="en-US" dirty="0" err="1"/>
@@ -11590,20 +11956,19 @@
               <a:t> bent in je </a:t>
             </a:r>
             <a:r>
-              <a:rPr lang="en-US" dirty="0" err="1"/>
+              <a:rPr lang="en-US" i="1" err="1"/>
               <a:t>geheugen</a:t>
             </a:r>
             <a:r>
-              <a:rPr lang="en-US" dirty="0"/>
+              <a:rPr lang="en-US"/>
               <a:t> </a:t>
             </a:r>
-            <a:r>
-              <a:rPr lang="en-US" dirty="0" err="1"/>
-              <a:t>en</a:t>
-            </a:r>
-            <a:r>
-              <a:rPr lang="en-US" dirty="0"/>
-              <a:t> </a:t>
+            <a:br>
+              <a:rPr lang="en-US"/>
+            </a:br>
+            <a:r>
+              <a:rPr lang="en-US"/>
+              <a:t>en </a:t>
             </a:r>
             <a:r>
               <a:rPr lang="en-US" dirty="0" err="1"/>
@@ -11619,7 +11984,15 @@
             </a:r>
             <a:r>
               <a:rPr lang="en-US" dirty="0"/>
-              <a:t> performance wilt?</a:t>
+              <a:t> </a:t>
+            </a:r>
+            <a:r>
+              <a:rPr lang="en-US" i="1" dirty="0"/>
+              <a:t>performance</a:t>
+            </a:r>
+            <a:r>
+              <a:rPr lang="en-US" dirty="0"/>
+              <a:t> wilt?</a:t>
             </a:r>
           </a:p>
           <a:p>
@@ -11644,12 +12017,12 @@
               <a:t> </a:t>
             </a:r>
             <a:r>
-              <a:rPr lang="en-US" dirty="0" err="1"/>
+              <a:rPr lang="en-US" err="1"/>
               <a:t>aan</a:t>
             </a:r>
             <a:r>
-              <a:rPr lang="en-US" dirty="0"/>
-              <a:t> wilt </a:t>
+              <a:rPr lang="en-US"/>
+              <a:t> wil </a:t>
             </a:r>
             <a:r>
               <a:rPr lang="en-US" dirty="0" err="1"/>
@@ -11690,7 +12063,7 @@
               <a:t> </a:t>
             </a:r>
             <a:r>
-              <a:rPr lang="fr-FR" sz="2800" dirty="0" err="1">
+              <a:rPr lang="fr-FR" sz="2800" err="1">
                 <a:solidFill>
                   <a:srgbClr val="000000"/>
                 </a:solidFill>
@@ -11701,7 +12074,7 @@
               <a:t>func</a:t>
             </a:r>
             <a:r>
-              <a:rPr lang="fr-FR" sz="2800" b="1" dirty="0">
+              <a:rPr lang="fr-FR" sz="2800" b="1">
                 <a:solidFill>
                   <a:srgbClr val="000080"/>
                 </a:solidFill>
@@ -11709,7 +12082,29 @@
                   <a:srgbClr val="FFFFFF"/>
                 </a:highlight>
               </a:rPr>
-              <a:t>(</a:t>
+              <a:t>( </a:t>
+            </a:r>
+            <a:r>
+              <a:rPr lang="fr-FR" sz="2800" b="0">
+                <a:solidFill>
+                  <a:srgbClr val="8000FF"/>
+                </a:solidFill>
+                <a:highlight>
+                  <a:srgbClr val="FFFFFF"/>
+                </a:highlight>
+              </a:rPr>
+              <a:t>const</a:t>
+            </a:r>
+            <a:r>
+              <a:rPr lang="fr-FR" sz="2800" b="0">
+                <a:solidFill>
+                  <a:srgbClr val="000000"/>
+                </a:solidFill>
+                <a:highlight>
+                  <a:srgbClr val="FFFFFF"/>
+                </a:highlight>
+              </a:rPr>
+              <a:t> </a:t>
             </a:r>
             <a:r>
               <a:rPr lang="fr-FR" sz="2800" b="0" dirty="0" err="1">
@@ -11720,10 +12115,21 @@
                   <a:srgbClr val="FFFFFF"/>
                 </a:highlight>
               </a:rPr>
-              <a:t>const</a:t>
-            </a:r>
-            <a:r>
-              <a:rPr lang="fr-FR" sz="2800" b="0" dirty="0">
+              <a:t>int</a:t>
+            </a:r>
+            <a:r>
+              <a:rPr lang="fr-FR" sz="2800" b="1">
+                <a:solidFill>
+                  <a:srgbClr val="000080"/>
+                </a:solidFill>
+                <a:highlight>
+                  <a:srgbClr val="FFFFFF"/>
+                </a:highlight>
+              </a:rPr>
+              <a:t>&amp;</a:t>
+            </a:r>
+            <a:r>
+              <a:rPr lang="fr-FR" sz="2800" b="0">
                 <a:solidFill>
                   <a:srgbClr val="000000"/>
                 </a:solidFill>
@@ -11731,63 +12137,38 @@
                   <a:srgbClr val="FFFFFF"/>
                 </a:highlight>
               </a:rPr>
+              <a:t> param </a:t>
+            </a:r>
+            <a:r>
+              <a:rPr lang="fr-FR" sz="2800" b="1">
+                <a:solidFill>
+                  <a:srgbClr val="000080"/>
+                </a:solidFill>
+                <a:highlight>
+                  <a:srgbClr val="FFFFFF"/>
+                </a:highlight>
+              </a:rPr>
+              <a:t>) {</a:t>
+            </a:r>
+            <a:r>
+              <a:rPr lang="fr-FR" sz="2800" b="0">
+                <a:solidFill>
+                  <a:srgbClr val="000000"/>
+                </a:solidFill>
+                <a:highlight>
+                  <a:srgbClr val="FFFFFF"/>
+                </a:highlight>
+              </a:rPr>
               <a:t> </a:t>
             </a:r>
-            <a:r>
-              <a:rPr lang="fr-FR" sz="2800" b="0" dirty="0" err="1">
-                <a:solidFill>
-                  <a:srgbClr val="8000FF"/>
-                </a:solidFill>
-                <a:highlight>
-                  <a:srgbClr val="FFFFFF"/>
-                </a:highlight>
-              </a:rPr>
-              <a:t>int</a:t>
-            </a:r>
-            <a:r>
-              <a:rPr lang="fr-FR" sz="2800" b="1" dirty="0">
-                <a:solidFill>
-                  <a:srgbClr val="000080"/>
-                </a:solidFill>
-                <a:highlight>
-                  <a:srgbClr val="FFFFFF"/>
-                </a:highlight>
-              </a:rPr>
-              <a:t>&amp;</a:t>
-            </a:r>
-            <a:r>
-              <a:rPr lang="fr-FR" sz="2800" b="0" dirty="0">
-                <a:solidFill>
-                  <a:srgbClr val="000000"/>
-                </a:solidFill>
-                <a:highlight>
-                  <a:srgbClr val="FFFFFF"/>
-                </a:highlight>
-              </a:rPr>
-              <a:t> param</a:t>
-            </a:r>
-            <a:r>
-              <a:rPr lang="fr-FR" sz="2800" b="1" dirty="0">
-                <a:solidFill>
-                  <a:srgbClr val="000080"/>
-                </a:solidFill>
-                <a:highlight>
-                  <a:srgbClr val="FFFFFF"/>
-                </a:highlight>
-              </a:rPr>
-              <a:t>){</a:t>
-            </a:r>
-            <a:r>
-              <a:rPr lang="fr-FR" sz="2800" b="0" dirty="0">
-                <a:solidFill>
-                  <a:srgbClr val="000000"/>
-                </a:solidFill>
-                <a:highlight>
-                  <a:srgbClr val="FFFFFF"/>
-                </a:highlight>
-              </a:rPr>
-              <a:t> </a:t>
-            </a:r>
+            <a:endParaRPr lang="fr-FR" sz="2800" b="0" dirty="0">
+              <a:solidFill>
+                <a:srgbClr val="000000"/>
+              </a:solidFill>
+              <a:highlight>
+                <a:srgbClr val="FFFFFF"/>
+              </a:highlight>
+            </a:endParaRPr>
           </a:p>
           <a:p>
             <a:pPr marL="0" indent="0">
@@ -11901,26 +12282,38 @@
               <a:t>gebruiken</a:t>
             </a:r>
             <a:r>
-              <a:rPr lang="en-US" dirty="0"/>
-              <a:t>? Const&amp; is </a:t>
-            </a:r>
-            <a:r>
-              <a:rPr lang="en-US" dirty="0" err="1"/>
+              <a:rPr lang="en-US"/>
+              <a:t>? </a:t>
+            </a:r>
+            <a:r>
+              <a:rPr lang="en-US" b="1" dirty="0"/>
+              <a:t>c</a:t>
+            </a:r>
+            <a:r>
+              <a:rPr lang="en-US" b="1"/>
+              <a:t>onst</a:t>
+            </a:r>
+            <a:r>
+              <a:rPr lang="en-US" b="1" dirty="0"/>
+              <a:t>&amp; is </a:t>
+            </a:r>
+            <a:r>
+              <a:rPr lang="en-US" b="1" dirty="0" err="1"/>
               <a:t>áltijd</a:t>
             </a:r>
             <a:r>
-              <a:rPr lang="en-US" dirty="0"/>
+              <a:rPr lang="en-US" b="1" dirty="0"/>
               <a:t> </a:t>
             </a:r>
             <a:r>
-              <a:rPr lang="en-US" dirty="0" err="1"/>
+              <a:rPr lang="en-US" b="1" dirty="0" err="1"/>
               <a:t>veilig</a:t>
             </a:r>
             <a:r>
-              <a:rPr lang="en-US" dirty="0"/>
+              <a:rPr lang="en-US" b="1" dirty="0"/>
               <a:t>!</a:t>
             </a:r>
-            <a:endParaRPr lang="en-NL" dirty="0"/>
+            <a:endParaRPr lang="en-NL" b="1" dirty="0"/>
           </a:p>
         </p:txBody>
       </p:sp>
@@ -12195,31 +12588,28 @@
           <a:lstStyle/>
           <a:p>
             <a:r>
-              <a:rPr lang="en-US" dirty="0" err="1"/>
-              <a:t>Functies</a:t>
-            </a:r>
-            <a:r>
-              <a:rPr lang="en-US" dirty="0"/>
-              <a:t>;</a:t>
-            </a:r>
+              <a:rPr lang="en-US"/>
+              <a:t>Functies:</a:t>
+            </a:r>
+            <a:endParaRPr lang="en-US" dirty="0"/>
           </a:p>
           <a:p>
             <a:pPr lvl="1"/>
             <a:r>
-              <a:rPr lang="en-US" dirty="0" err="1"/>
-              <a:t>Herbruikbaar</a:t>
-            </a:r>
-            <a:r>
-              <a:rPr lang="en-US" dirty="0"/>
-              <a:t> </a:t>
-            </a:r>
-            <a:r>
-              <a:rPr lang="en-US" dirty="0" err="1"/>
-              <a:t>stuk</a:t>
-            </a:r>
-            <a:r>
-              <a:rPr lang="en-US" dirty="0"/>
-              <a:t> code (named code block)</a:t>
+              <a:rPr lang="en-US"/>
+              <a:t>Hergebruik van </a:t>
+            </a:r>
+            <a:r>
+              <a:rPr lang="en-US" dirty="0"/>
+              <a:t>code </a:t>
+            </a:r>
+            <a:r>
+              <a:rPr lang="en-US"/>
+              <a:t>(named: </a:t>
+            </a:r>
+            <a:r>
+              <a:rPr lang="en-US" dirty="0"/>
+              <a:t>code block)</a:t>
             </a:r>
           </a:p>
           <a:p>
@@ -12253,8 +12643,12 @@
           <a:p>
             <a:pPr lvl="1"/>
             <a:r>
-              <a:rPr lang="en-US" dirty="0"/>
-              <a:t>Maar het return type mag </a:t>
+              <a:rPr lang="en-US"/>
+              <a:t>maar </a:t>
+            </a:r>
+            <a:r>
+              <a:rPr lang="en-US" dirty="0"/>
+              <a:t>het return type mag </a:t>
             </a:r>
             <a:r>
               <a:rPr lang="en-US" dirty="0" err="1"/>
@@ -12348,28 +12742,24 @@
               <a:t> </a:t>
             </a:r>
             <a:r>
-              <a:rPr lang="en-US" dirty="0" err="1"/>
+              <a:rPr lang="en-US" err="1"/>
               <a:t>niet</a:t>
             </a:r>
             <a:r>
-              <a:rPr lang="en-US" dirty="0"/>
+              <a:rPr lang="en-US"/>
               <a:t> </a:t>
             </a:r>
             <a:r>
-              <a:rPr lang="en-US" dirty="0" err="1"/>
-              <a:t>niets</a:t>
-            </a:r>
-            <a:r>
-              <a:rPr lang="en-US" dirty="0"/>
-              <a:t> </a:t>
-            </a:r>
-            <a:r>
-              <a:rPr lang="en-US" dirty="0" err="1"/>
-              <a:t>zijn</a:t>
-            </a:r>
-            <a:r>
-              <a:rPr lang="en-US" dirty="0"/>
-              <a:t>, maar je mag </a:t>
+              <a:rPr lang="en-US" i="1"/>
+              <a:t>void</a:t>
+            </a:r>
+            <a:r>
+              <a:rPr lang="en-US"/>
+              <a:t> zijn, </a:t>
+            </a:r>
+            <a:r>
+              <a:rPr lang="en-US" dirty="0"/>
+              <a:t>maar je mag </a:t>
             </a:r>
             <a:r>
               <a:rPr lang="en-US" dirty="0" err="1"/>
@@ -12587,19 +12977,11 @@
             </a:r>
             <a:r>
               <a:rPr lang="en-US" dirty="0"/>
-              <a:t> we het </a:t>
-            </a:r>
-            <a:r>
-              <a:rPr lang="en-US" dirty="0" err="1"/>
-              <a:t>hier</a:t>
-            </a:r>
-            <a:r>
-              <a:rPr lang="en-US" dirty="0"/>
-              <a:t> </a:t>
-            </a:r>
-            <a:r>
-              <a:rPr lang="en-US" dirty="0" err="1"/>
-              <a:t>bij</a:t>
+              <a:t> we </a:t>
+            </a:r>
+            <a:r>
+              <a:rPr lang="en-US"/>
+              <a:t>het hierbij</a:t>
             </a:r>
             <a:r>
               <a:rPr lang="en-US" dirty="0"/>
@@ -13997,8 +14379,8 @@
           <a:lstStyle/>
           <a:p>
             <a:r>
-              <a:rPr lang="en-US" dirty="0"/>
-              <a:t>Exact </a:t>
+              <a:rPr lang="en-US"/>
+              <a:t>Als je exact </a:t>
             </a:r>
             <a:r>
               <a:rPr lang="en-US" dirty="0" err="1"/>
@@ -14006,14 +14388,18 @@
             </a:r>
             <a:r>
               <a:rPr lang="en-US" dirty="0"/>
-              <a:t> hoe </a:t>
-            </a:r>
-            <a:r>
-              <a:rPr lang="en-US" dirty="0" err="1"/>
+              <a:t> </a:t>
+            </a:r>
+            <a:r>
+              <a:rPr lang="en-US" i="1" dirty="0"/>
+              <a:t>hoe </a:t>
+            </a:r>
+            <a:r>
+              <a:rPr lang="en-US" i="1" dirty="0" err="1"/>
               <a:t>vaak</a:t>
             </a:r>
             <a:r>
-              <a:rPr lang="en-US" dirty="0"/>
+              <a:rPr lang="en-US" i="1" dirty="0"/>
               <a:t> </a:t>
             </a:r>
             <a:r>
@@ -14091,27 +14477,35 @@
           <a:lstStyle/>
           <a:p>
             <a:r>
-              <a:rPr lang="en-US" dirty="0" err="1"/>
-              <a:t>Oneindig</a:t>
+              <a:rPr lang="en-US" i="1"/>
+              <a:t>Oneindige</a:t>
+            </a:r>
+            <a:r>
+              <a:rPr lang="en-US"/>
+              <a:t> loops</a:t>
             </a:r>
             <a:endParaRPr lang="en-US" dirty="0"/>
           </a:p>
           <a:p>
             <a:r>
-              <a:rPr lang="en-US" dirty="0" err="1"/>
+              <a:rPr lang="en-US" i="1" dirty="0" err="1"/>
               <a:t>Niet</a:t>
             </a:r>
             <a:r>
-              <a:rPr lang="en-US" dirty="0"/>
+              <a:rPr lang="en-US" i="1" dirty="0"/>
               <a:t> </a:t>
             </a:r>
             <a:r>
-              <a:rPr lang="en-US" dirty="0" err="1"/>
+              <a:rPr lang="en-US" i="1" dirty="0" err="1"/>
               <a:t>zeker</a:t>
             </a:r>
             <a:r>
-              <a:rPr lang="en-US" dirty="0"/>
-              <a:t> hoe lang tot </a:t>
+              <a:rPr lang="en-US" i="1" dirty="0"/>
+              <a:t> </a:t>
+            </a:r>
+            <a:r>
+              <a:rPr lang="en-US" dirty="0"/>
+              <a:t>hoe lang tot </a:t>
             </a:r>
             <a:r>
               <a:rPr lang="en-US" dirty="0" err="1"/>
@@ -14135,16 +14529,20 @@
           </a:p>
           <a:p>
             <a:r>
-              <a:rPr lang="en-US" dirty="0"/>
+              <a:rPr lang="en-US" i="1" dirty="0"/>
               <a:t>Andere </a:t>
             </a:r>
             <a:r>
-              <a:rPr lang="en-US" dirty="0" err="1"/>
+              <a:rPr lang="en-US" i="1" dirty="0" err="1"/>
               <a:t>conditie</a:t>
             </a:r>
             <a:r>
-              <a:rPr lang="en-US" dirty="0"/>
-              <a:t> dan </a:t>
+              <a:rPr lang="en-US" i="1" dirty="0"/>
+              <a:t> </a:t>
+            </a:r>
+            <a:r>
+              <a:rPr lang="en-US" dirty="0"/>
+              <a:t>dan </a:t>
             </a:r>
             <a:r>
               <a:rPr lang="en-US" dirty="0" err="1"/>
@@ -14586,10 +14984,21 @@
                   <a:srgbClr val="FFFFFF"/>
                 </a:highlight>
               </a:rPr>
-              <a:t> 	</a:t>
-            </a:r>
-            <a:r>
-              <a:rPr lang="nl-NL" sz="2800" b="1" dirty="0">
+              <a:t> </a:t>
+            </a:r>
+            <a:r>
+              <a:rPr lang="nl-NL" sz="2800" b="0">
+                <a:solidFill>
+                  <a:srgbClr val="000000"/>
+                </a:solidFill>
+                <a:highlight>
+                  <a:srgbClr val="FFFFFF"/>
+                </a:highlight>
+              </a:rPr>
+              <a:t>	</a:t>
+            </a:r>
+            <a:r>
+              <a:rPr lang="nl-NL" sz="2800" b="1">
                 <a:solidFill>
                   <a:srgbClr val="000080"/>
                 </a:solidFill>
@@ -14597,10 +15006,10 @@
                   <a:srgbClr val="FFFFFF"/>
                 </a:highlight>
               </a:rPr>
-              <a:t>{</a:t>
-            </a:r>
-            <a:r>
-              <a:rPr lang="nl-NL" sz="2800" b="0" dirty="0">
+              <a:t>{ </a:t>
+            </a:r>
+            <a:r>
+              <a:rPr lang="nl-NL" sz="2800" b="0">
                 <a:solidFill>
                   <a:srgbClr val="FF8000"/>
                 </a:solidFill>
@@ -14611,7 +15020,7 @@
               <a:t>5</a:t>
             </a:r>
             <a:r>
-              <a:rPr lang="nl-NL" sz="2800" b="1" dirty="0">
+              <a:rPr lang="nl-NL" sz="2800" b="1">
                 <a:solidFill>
                   <a:srgbClr val="000080"/>
                 </a:solidFill>
@@ -14619,10 +15028,10 @@
                   <a:srgbClr val="FFFFFF"/>
                 </a:highlight>
               </a:rPr>
-              <a:t>,</a:t>
-            </a:r>
-            <a:r>
-              <a:rPr lang="nl-NL" dirty="0">
+              <a:t>, </a:t>
+            </a:r>
+            <a:r>
+              <a:rPr lang="nl-NL">
                 <a:solidFill>
                   <a:srgbClr val="FF8000"/>
                 </a:solidFill>
@@ -14630,10 +15039,10 @@
                   <a:srgbClr val="FFFFFF"/>
                 </a:highlight>
               </a:rPr>
-              <a:t>3</a:t>
-            </a:r>
-            <a:r>
-              <a:rPr lang="nl-NL" sz="2800" b="1" dirty="0">
+              <a:t>3 </a:t>
+            </a:r>
+            <a:r>
+              <a:rPr lang="nl-NL" sz="2800" b="1">
                 <a:solidFill>
                   <a:srgbClr val="000080"/>
                 </a:solidFill>
@@ -14643,6 +15052,14 @@
               </a:rPr>
               <a:t>};</a:t>
             </a:r>
+            <a:endParaRPr lang="nl-NL" sz="2800" b="1" dirty="0">
+              <a:solidFill>
+                <a:srgbClr val="000080"/>
+              </a:solidFill>
+              <a:highlight>
+                <a:srgbClr val="FFFFFF"/>
+              </a:highlight>
+            </a:endParaRPr>
           </a:p>
           <a:p>
             <a:pPr marL="0" indent="0">
@@ -15043,8 +15460,8 @@
           <a:lstStyle/>
           <a:p>
             <a:r>
-              <a:rPr lang="en-US" dirty="0" err="1"/>
-              <a:t>Functies</a:t>
+              <a:rPr lang="en-US"/>
+              <a:t>Functies (1 van 2)</a:t>
             </a:r>
             <a:endParaRPr lang="en-NL" dirty="0"/>
           </a:p>
@@ -15311,10 +15728,21 @@
                   <a:srgbClr val="FFFFFF"/>
                 </a:highlight>
               </a:rPr>
-              <a:t> func</a:t>
-            </a:r>
-            <a:r>
-              <a:rPr lang="nl-NL" sz="2800" b="1" dirty="0">
+              <a:t> </a:t>
+            </a:r>
+            <a:r>
+              <a:rPr lang="nl-NL" sz="2800">
+                <a:solidFill>
+                  <a:srgbClr val="000000"/>
+                </a:solidFill>
+                <a:highlight>
+                  <a:srgbClr val="FFFFFF"/>
+                </a:highlight>
+              </a:rPr>
+              <a:t>func</a:t>
+            </a:r>
+            <a:r>
+              <a:rPr lang="nl-NL" sz="2800" b="1">
                 <a:solidFill>
                   <a:srgbClr val="000080"/>
                 </a:solidFill>
@@ -15322,7 +15750,7 @@
                   <a:srgbClr val="FFFFFF"/>
                 </a:highlight>
               </a:rPr>
-              <a:t>(){</a:t>
+              <a:t>() {</a:t>
             </a:r>
             <a:endParaRPr lang="nl-NL" sz="2800" b="0" dirty="0">
               <a:solidFill>
@@ -15619,8 +16047,8 @@
           <a:lstStyle/>
           <a:p>
             <a:r>
-              <a:rPr lang="en-US" dirty="0" err="1"/>
-              <a:t>Functies</a:t>
+              <a:rPr lang="en-US"/>
+              <a:t>Functies (2 van 2)</a:t>
             </a:r>
             <a:endParaRPr lang="en-NL" dirty="0"/>
           </a:p>
@@ -15642,7 +16070,12 @@
             <p:ph sz="half" idx="1"/>
           </p:nvPr>
         </p:nvSpPr>
-        <p:spPr/>
+        <p:spPr>
+          <a:xfrm>
+            <a:off x="838200" y="2599533"/>
+            <a:ext cx="5181600" cy="3577430"/>
+          </a:xfrm>
+        </p:spPr>
         <p:txBody>
           <a:bodyPr/>
           <a:lstStyle/>
@@ -15790,7 +16223,12 @@
             <p:ph sz="half" idx="2"/>
           </p:nvPr>
         </p:nvSpPr>
-        <p:spPr/>
+        <p:spPr>
+          <a:xfrm>
+            <a:off x="6172200" y="2599533"/>
+            <a:ext cx="5181600" cy="3577430"/>
+          </a:xfrm>
+        </p:spPr>
         <p:txBody>
           <a:bodyPr/>
           <a:lstStyle/>
@@ -15837,65 +16275,87 @@
                   <a:srgbClr val="FFFFFF"/>
                 </a:highlight>
               </a:rPr>
-              <a:t> func</a:t>
+              <a:t> </a:t>
+            </a:r>
+            <a:r>
+              <a:rPr lang="nl-NL" sz="2800">
+                <a:solidFill>
+                  <a:srgbClr val="000000"/>
+                </a:solidFill>
+                <a:highlight>
+                  <a:srgbClr val="FFFFFF"/>
+                </a:highlight>
+              </a:rPr>
+              <a:t>func</a:t>
+            </a:r>
+            <a:r>
+              <a:rPr lang="nl-NL" sz="2800" b="1">
+                <a:solidFill>
+                  <a:srgbClr val="000080"/>
+                </a:solidFill>
+                <a:highlight>
+                  <a:srgbClr val="FFFFFF"/>
+                </a:highlight>
+              </a:rPr>
+              <a:t>() {</a:t>
+            </a:r>
+            <a:r>
+              <a:rPr lang="nl-NL">
+                <a:solidFill>
+                  <a:srgbClr val="000000"/>
+                </a:solidFill>
+                <a:highlight>
+                  <a:srgbClr val="FFFFFF"/>
+                </a:highlight>
+              </a:rPr>
+              <a:t> </a:t>
             </a:r>
             <a:r>
               <a:rPr lang="nl-NL" sz="2800" b="1" dirty="0">
                 <a:solidFill>
+                  <a:srgbClr val="0000FF"/>
+                </a:solidFill>
+                <a:highlight>
+                  <a:srgbClr val="FFFFFF"/>
+                </a:highlight>
+              </a:rPr>
+              <a:t>return</a:t>
+            </a:r>
+            <a:r>
+              <a:rPr lang="nl-NL" sz="2800" b="0" dirty="0">
+                <a:solidFill>
+                  <a:srgbClr val="000000"/>
+                </a:solidFill>
+                <a:highlight>
+                  <a:srgbClr val="FFFFFF"/>
+                </a:highlight>
+              </a:rPr>
+              <a:t> </a:t>
+            </a:r>
+            <a:r>
+              <a:rPr lang="nl-NL" sz="2800" b="0">
+                <a:solidFill>
+                  <a:srgbClr val="FF8000"/>
+                </a:solidFill>
+                <a:highlight>
+                  <a:srgbClr val="FFFFFF"/>
+                </a:highlight>
+              </a:rPr>
+              <a:t>10</a:t>
+            </a:r>
+            <a:r>
+              <a:rPr lang="nl-NL" sz="2800" b="1">
+                <a:solidFill>
                   <a:srgbClr val="000080"/>
                 </a:solidFill>
                 <a:highlight>
                   <a:srgbClr val="FFFFFF"/>
                 </a:highlight>
               </a:rPr>
-              <a:t>(){</a:t>
-            </a:r>
-            <a:r>
-              <a:rPr lang="nl-NL" dirty="0">
-                <a:solidFill>
-                  <a:srgbClr val="000000"/>
-                </a:solidFill>
-                <a:highlight>
-                  <a:srgbClr val="FFFFFF"/>
-                </a:highlight>
-              </a:rPr>
-              <a:t> </a:t>
-            </a:r>
-            <a:r>
-              <a:rPr lang="nl-NL" sz="2800" b="1" dirty="0">
-                <a:solidFill>
-                  <a:srgbClr val="0000FF"/>
-                </a:solidFill>
-                <a:highlight>
-                  <a:srgbClr val="FFFFFF"/>
-                </a:highlight>
-              </a:rPr>
-              <a:t>return</a:t>
-            </a:r>
-            <a:r>
-              <a:rPr lang="nl-NL" sz="2800" b="0" dirty="0">
-                <a:solidFill>
-                  <a:srgbClr val="000000"/>
-                </a:solidFill>
-                <a:highlight>
-                  <a:srgbClr val="FFFFFF"/>
-                </a:highlight>
-              </a:rPr>
-              <a:t> </a:t>
-            </a:r>
-            <a:r>
-              <a:rPr lang="nl-NL" sz="2800" b="0" dirty="0">
-                <a:solidFill>
-                  <a:srgbClr val="FF8000"/>
-                </a:solidFill>
-                <a:highlight>
-                  <a:srgbClr val="FFFFFF"/>
-                </a:highlight>
-              </a:rPr>
-              <a:t>10</a:t>
-            </a:r>
-            <a:r>
-              <a:rPr lang="nl-NL" sz="2800" b="1" dirty="0">
+              <a:t>; </a:t>
+            </a:r>
+            <a:r>
+              <a:rPr lang="en-NL" sz="2800" b="1">
                 <a:solidFill>
                   <a:srgbClr val="000080"/>
                 </a:solidFill>
@@ -15903,18 +16363,210 @@
                   <a:srgbClr val="FFFFFF"/>
                 </a:highlight>
               </a:rPr>
-              <a:t>;</a:t>
-            </a:r>
-            <a:r>
-              <a:rPr lang="en-NL" sz="2800" b="1" dirty="0">
-                <a:solidFill>
-                  <a:srgbClr val="000080"/>
-                </a:solidFill>
-                <a:highlight>
-                  <a:srgbClr val="FFFFFF"/>
-                </a:highlight>
-              </a:rPr>
               <a:t>}</a:t>
+            </a:r>
+            <a:endParaRPr lang="en-NL" dirty="0"/>
+          </a:p>
+        </p:txBody>
+      </p:sp>
+      <p:sp>
+        <p:nvSpPr>
+          <p:cNvPr id="5" name="Text Placeholder 4">
+            <a:extLst>
+              <a:ext uri="{FF2B5EF4-FFF2-40B4-BE49-F238E27FC236}">
+                <a16:creationId xmlns:a16="http://schemas.microsoft.com/office/drawing/2014/main" id="{E99F2D4A-86AC-77C5-FA79-FA361D984971}"/>
+              </a:ext>
+            </a:extLst>
+          </p:cNvPr>
+          <p:cNvSpPr txBox="1">
+            <a:spLocks/>
+          </p:cNvSpPr>
+          <p:nvPr/>
+        </p:nvSpPr>
+        <p:spPr>
+          <a:xfrm>
+            <a:off x="839788" y="1690688"/>
+            <a:ext cx="10512424" cy="823912"/>
+          </a:xfrm>
+          <a:prstGeom prst="rect">
+            <a:avLst/>
+          </a:prstGeom>
+        </p:spPr>
+        <p:txBody>
+          <a:bodyPr vert="horz" lIns="91440" tIns="45720" rIns="91440" bIns="45720" rtlCol="0">
+            <a:normAutofit/>
+          </a:bodyPr>
+          <a:lstStyle>
+            <a:lvl1pPr marL="228600" indent="-228600" algn="l" defTabSz="914400" rtl="0" eaLnBrk="1" latinLnBrk="0" hangingPunct="1">
+              <a:lnSpc>
+                <a:spcPct val="90000"/>
+              </a:lnSpc>
+              <a:spcBef>
+                <a:spcPts val="1000"/>
+              </a:spcBef>
+              <a:buFont typeface="Arial" panose="020B0604020202020204" pitchFamily="34" charset="0"/>
+              <a:buChar char="•"/>
+              <a:defRPr sz="2800" kern="1200">
+                <a:solidFill>
+                  <a:schemeClr val="tx1"/>
+                </a:solidFill>
+                <a:latin typeface="+mn-lt"/>
+                <a:ea typeface="+mn-ea"/>
+                <a:cs typeface="+mn-cs"/>
+              </a:defRPr>
+            </a:lvl1pPr>
+            <a:lvl2pPr marL="685800" indent="-228600" algn="l" defTabSz="914400" rtl="0" eaLnBrk="1" latinLnBrk="0" hangingPunct="1">
+              <a:lnSpc>
+                <a:spcPct val="90000"/>
+              </a:lnSpc>
+              <a:spcBef>
+                <a:spcPts val="500"/>
+              </a:spcBef>
+              <a:buFont typeface="Arial" panose="020B0604020202020204" pitchFamily="34" charset="0"/>
+              <a:buChar char="•"/>
+              <a:defRPr sz="2400" kern="1200">
+                <a:solidFill>
+                  <a:schemeClr val="tx1"/>
+                </a:solidFill>
+                <a:latin typeface="+mn-lt"/>
+                <a:ea typeface="+mn-ea"/>
+                <a:cs typeface="+mn-cs"/>
+              </a:defRPr>
+            </a:lvl2pPr>
+            <a:lvl3pPr marL="1143000" indent="-228600" algn="l" defTabSz="914400" rtl="0" eaLnBrk="1" latinLnBrk="0" hangingPunct="1">
+              <a:lnSpc>
+                <a:spcPct val="90000"/>
+              </a:lnSpc>
+              <a:spcBef>
+                <a:spcPts val="500"/>
+              </a:spcBef>
+              <a:buFont typeface="Arial" panose="020B0604020202020204" pitchFamily="34" charset="0"/>
+              <a:buChar char="•"/>
+              <a:defRPr sz="2000" kern="1200">
+                <a:solidFill>
+                  <a:schemeClr val="tx1"/>
+                </a:solidFill>
+                <a:latin typeface="+mn-lt"/>
+                <a:ea typeface="+mn-ea"/>
+                <a:cs typeface="+mn-cs"/>
+              </a:defRPr>
+            </a:lvl3pPr>
+            <a:lvl4pPr marL="1600200" indent="-228600" algn="l" defTabSz="914400" rtl="0" eaLnBrk="1" latinLnBrk="0" hangingPunct="1">
+              <a:lnSpc>
+                <a:spcPct val="90000"/>
+              </a:lnSpc>
+              <a:spcBef>
+                <a:spcPts val="500"/>
+              </a:spcBef>
+              <a:buFont typeface="Arial" panose="020B0604020202020204" pitchFamily="34" charset="0"/>
+              <a:buChar char="•"/>
+              <a:defRPr sz="1800" kern="1200">
+                <a:solidFill>
+                  <a:schemeClr val="tx1"/>
+                </a:solidFill>
+                <a:latin typeface="+mn-lt"/>
+                <a:ea typeface="+mn-ea"/>
+                <a:cs typeface="+mn-cs"/>
+              </a:defRPr>
+            </a:lvl4pPr>
+            <a:lvl5pPr marL="2057400" indent="-228600" algn="l" defTabSz="914400" rtl="0" eaLnBrk="1" latinLnBrk="0" hangingPunct="1">
+              <a:lnSpc>
+                <a:spcPct val="90000"/>
+              </a:lnSpc>
+              <a:spcBef>
+                <a:spcPts val="500"/>
+              </a:spcBef>
+              <a:buFont typeface="Arial" panose="020B0604020202020204" pitchFamily="34" charset="0"/>
+              <a:buChar char="•"/>
+              <a:defRPr sz="1800" kern="1200">
+                <a:solidFill>
+                  <a:schemeClr val="tx1"/>
+                </a:solidFill>
+                <a:latin typeface="+mn-lt"/>
+                <a:ea typeface="+mn-ea"/>
+                <a:cs typeface="+mn-cs"/>
+              </a:defRPr>
+            </a:lvl5pPr>
+            <a:lvl6pPr marL="2514600" indent="-228600" algn="l" defTabSz="914400" rtl="0" eaLnBrk="1" latinLnBrk="0" hangingPunct="1">
+              <a:lnSpc>
+                <a:spcPct val="90000"/>
+              </a:lnSpc>
+              <a:spcBef>
+                <a:spcPts val="500"/>
+              </a:spcBef>
+              <a:buFont typeface="Arial" panose="020B0604020202020204" pitchFamily="34" charset="0"/>
+              <a:buChar char="•"/>
+              <a:defRPr sz="1800" kern="1200">
+                <a:solidFill>
+                  <a:schemeClr val="tx1"/>
+                </a:solidFill>
+                <a:latin typeface="+mn-lt"/>
+                <a:ea typeface="+mn-ea"/>
+                <a:cs typeface="+mn-cs"/>
+              </a:defRPr>
+            </a:lvl6pPr>
+            <a:lvl7pPr marL="2971800" indent="-228600" algn="l" defTabSz="914400" rtl="0" eaLnBrk="1" latinLnBrk="0" hangingPunct="1">
+              <a:lnSpc>
+                <a:spcPct val="90000"/>
+              </a:lnSpc>
+              <a:spcBef>
+                <a:spcPts val="500"/>
+              </a:spcBef>
+              <a:buFont typeface="Arial" panose="020B0604020202020204" pitchFamily="34" charset="0"/>
+              <a:buChar char="•"/>
+              <a:defRPr sz="1800" kern="1200">
+                <a:solidFill>
+                  <a:schemeClr val="tx1"/>
+                </a:solidFill>
+                <a:latin typeface="+mn-lt"/>
+                <a:ea typeface="+mn-ea"/>
+                <a:cs typeface="+mn-cs"/>
+              </a:defRPr>
+            </a:lvl7pPr>
+            <a:lvl8pPr marL="3429000" indent="-228600" algn="l" defTabSz="914400" rtl="0" eaLnBrk="1" latinLnBrk="0" hangingPunct="1">
+              <a:lnSpc>
+                <a:spcPct val="90000"/>
+              </a:lnSpc>
+              <a:spcBef>
+                <a:spcPts val="500"/>
+              </a:spcBef>
+              <a:buFont typeface="Arial" panose="020B0604020202020204" pitchFamily="34" charset="0"/>
+              <a:buChar char="•"/>
+              <a:defRPr sz="1800" kern="1200">
+                <a:solidFill>
+                  <a:schemeClr val="tx1"/>
+                </a:solidFill>
+                <a:latin typeface="+mn-lt"/>
+                <a:ea typeface="+mn-ea"/>
+                <a:cs typeface="+mn-cs"/>
+              </a:defRPr>
+            </a:lvl8pPr>
+            <a:lvl9pPr marL="3886200" indent="-228600" algn="l" defTabSz="914400" rtl="0" eaLnBrk="1" latinLnBrk="0" hangingPunct="1">
+              <a:lnSpc>
+                <a:spcPct val="90000"/>
+              </a:lnSpc>
+              <a:spcBef>
+                <a:spcPts val="500"/>
+              </a:spcBef>
+              <a:buFont typeface="Arial" panose="020B0604020202020204" pitchFamily="34" charset="0"/>
+              <a:buChar char="•"/>
+              <a:defRPr sz="1800" kern="1200">
+                <a:solidFill>
+                  <a:schemeClr val="tx1"/>
+                </a:solidFill>
+                <a:latin typeface="+mn-lt"/>
+                <a:ea typeface="+mn-ea"/>
+                <a:cs typeface="+mn-cs"/>
+              </a:defRPr>
+            </a:lvl9pPr>
+          </a:lstStyle>
+          <a:p>
+            <a:pPr marL="0" indent="0">
+              <a:buNone/>
+            </a:pPr>
+            <a:r>
+              <a:rPr lang="en-US"/>
+              <a:t>Belang van indentatie (Python) geldt niet in C++ </a:t>
             </a:r>
             <a:endParaRPr lang="en-NL" dirty="0"/>
           </a:p>

</xml_diff>